<commit_message>
Replace submission deck's process-flow and architecture bullet lists with real diagrams
Remove the template's own "Note: Please download this template..."
instructional slide (python-pptx has no native slide-removal API, so
drop_rel + _sldIdLst removal was added as a helper). Rebuild the
process-flow and architecture slides as native boxes-and-arrows
diagrams (rounded-rectangle nodes, down-arrows, left-side layer
labels, callout footer) instead of plain bullet text, styled after
the layered-box diagramming approach in the referenced SupplyMind
submission deck.

Co-Authored-By: Claude Sonnet 5 <noreply@anthropic.com>
</commit_message>
<xml_diff>
--- a/docs/Kisan_Mitra_Submission.pptx
+++ b/docs/Kisan_Mitra_Submission.pptx
@@ -9,18 +9,18 @@
   </p:notesMasterIdLst>
   <p:sldIdLst>
     <p:sldId id="256" r:id="rId2"/>
-    <p:sldId id="257" r:id="rId3"/>
-    <p:sldId id="258" r:id="rId4"/>
-    <p:sldId id="259" r:id="rId5"/>
-    <p:sldId id="260" r:id="rId6"/>
-    <p:sldId id="261" r:id="rId7"/>
-    <p:sldId id="262" r:id="rId8"/>
-    <p:sldId id="263" r:id="rId9"/>
-    <p:sldId id="264" r:id="rId10"/>
-    <p:sldId id="265" r:id="rId11"/>
-    <p:sldId id="266" r:id="rId12"/>
-    <p:sldId id="267" r:id="rId13"/>
-    <p:sldId id="268" r:id="rId14"/>
+    <p:sldId id="258" r:id="rId3"/>
+    <p:sldId id="259" r:id="rId4"/>
+    <p:sldId id="260" r:id="rId5"/>
+    <p:sldId id="261" r:id="rId6"/>
+    <p:sldId id="262" r:id="rId7"/>
+    <p:sldId id="263" r:id="rId8"/>
+    <p:sldId id="264" r:id="rId9"/>
+    <p:sldId id="265" r:id="rId10"/>
+    <p:sldId id="266" r:id="rId11"/>
+    <p:sldId id="267" r:id="rId12"/>
+    <p:sldId id="268" r:id="rId13"/>
+    <p:sldId id="272" r:id="rId14"/>
     <p:sldId id="269" r:id="rId15"/>
     <p:sldId id="270" r:id="rId16"/>
     <p:sldId id="271" r:id="rId17"/>
@@ -842,7 +842,7 @@
   <p:cSld>
     <p:spTree>
       <p:nvGrpSpPr>
-        <p:cNvPr id="1" name="Shape 120"/>
+        <p:cNvPr id="1" name="Shape 128"/>
         <p:cNvGrpSpPr/>
         <p:nvPr/>
       </p:nvGrpSpPr>
@@ -856,7 +856,7 @@
       </p:grpSpPr>
       <p:sp>
         <p:nvSpPr>
-          <p:cNvPr id="121" name="Google Shape;121;g3fb085bff3c_0_41:notes"/>
+          <p:cNvPr id="129" name="Google Shape;129;g3fb085bff3c_0_46:notes"/>
           <p:cNvSpPr>
             <a:spLocks noGrp="1" noRot="1" noChangeAspect="1"/>
           </p:cNvSpPr>
@@ -897,7 +897,7 @@
       </p:sp>
       <p:sp>
         <p:nvSpPr>
-          <p:cNvPr id="122" name="Google Shape;122;g3fb085bff3c_0_41:notes"/>
+          <p:cNvPr id="130" name="Google Shape;130;g3fb085bff3c_0_46:notes"/>
           <p:cNvSpPr txBox="1">
             <a:spLocks noGrp="1"/>
           </p:cNvSpPr>
@@ -942,110 +942,6 @@
 </file>
 
 <file path=ppt/notesSlides/notesSlide11.xml><?xml version="1.0" encoding="utf-8"?>
-<p:notes xmlns:a="http://schemas.openxmlformats.org/drawingml/2006/main" xmlns:r="http://schemas.openxmlformats.org/officeDocument/2006/relationships" xmlns:p="http://schemas.openxmlformats.org/presentationml/2006/main" showMasterSp="0" showMasterPhAnim="0">
-  <p:cSld>
-    <p:spTree>
-      <p:nvGrpSpPr>
-        <p:cNvPr id="1" name="Shape 128"/>
-        <p:cNvGrpSpPr/>
-        <p:nvPr/>
-      </p:nvGrpSpPr>
-      <p:grpSpPr>
-        <a:xfrm>
-          <a:off x="0" y="0"/>
-          <a:ext cx="0" cy="0"/>
-          <a:chOff x="0" y="0"/>
-          <a:chExt cx="0" cy="0"/>
-        </a:xfrm>
-      </p:grpSpPr>
-      <p:sp>
-        <p:nvSpPr>
-          <p:cNvPr id="129" name="Google Shape;129;g3fb085bff3c_0_46:notes"/>
-          <p:cNvSpPr>
-            <a:spLocks noGrp="1" noRot="1" noChangeAspect="1"/>
-          </p:cNvSpPr>
-          <p:nvPr>
-            <p:ph type="sldImg" idx="2"/>
-          </p:nvPr>
-        </p:nvSpPr>
-        <p:spPr>
-          <a:xfrm>
-            <a:off x="381300" y="685800"/>
-            <a:ext cx="6096000" cy="3429000"/>
-          </a:xfrm>
-          <a:custGeom>
-            <a:avLst/>
-            <a:gdLst/>
-            <a:ahLst/>
-            <a:cxnLst/>
-            <a:rect l="l" t="t" r="r" b="b"/>
-            <a:pathLst>
-              <a:path w="120000" h="120000" extrusionOk="0">
-                <a:moveTo>
-                  <a:pt x="0" y="0"/>
-                </a:moveTo>
-                <a:lnTo>
-                  <a:pt x="120000" y="0"/>
-                </a:lnTo>
-                <a:lnTo>
-                  <a:pt x="120000" y="120000"/>
-                </a:lnTo>
-                <a:lnTo>
-                  <a:pt x="0" y="120000"/>
-                </a:lnTo>
-                <a:close/>
-              </a:path>
-            </a:pathLst>
-          </a:custGeom>
-        </p:spPr>
-      </p:sp>
-      <p:sp>
-        <p:nvSpPr>
-          <p:cNvPr id="130" name="Google Shape;130;g3fb085bff3c_0_46:notes"/>
-          <p:cNvSpPr txBox="1">
-            <a:spLocks noGrp="1"/>
-          </p:cNvSpPr>
-          <p:nvPr>
-            <p:ph type="body" idx="1"/>
-          </p:nvPr>
-        </p:nvSpPr>
-        <p:spPr>
-          <a:xfrm>
-            <a:off x="685800" y="4343400"/>
-            <a:ext cx="5486400" cy="4114800"/>
-          </a:xfrm>
-          <a:prstGeom prst="rect">
-            <a:avLst/>
-          </a:prstGeom>
-        </p:spPr>
-        <p:txBody>
-          <a:bodyPr spcFirstLastPara="1" wrap="square" lIns="91425" tIns="91425" rIns="91425" bIns="91425" anchor="t" anchorCtr="0">
-            <a:noAutofit/>
-          </a:bodyPr>
-          <a:lstStyle/>
-          <a:p>
-            <a:pPr marL="0" lvl="0" indent="0" algn="l" rtl="0">
-              <a:spcBef>
-                <a:spcPts val="0"/>
-              </a:spcBef>
-              <a:spcAft>
-                <a:spcPts val="0"/>
-              </a:spcAft>
-              <a:buNone/>
-            </a:pPr>
-            <a:endParaRPr/>
-          </a:p>
-        </p:txBody>
-      </p:sp>
-    </p:spTree>
-  </p:cSld>
-  <p:clrMapOvr>
-    <a:masterClrMapping/>
-  </p:clrMapOvr>
-</p:notes>
-</file>
-
-<file path=ppt/notesSlides/notesSlide12.xml><?xml version="1.0" encoding="utf-8"?>
 <p:notes xmlns:a="http://schemas.openxmlformats.org/drawingml/2006/main" xmlns:r="http://schemas.openxmlformats.org/officeDocument/2006/relationships" xmlns:p="http://schemas.openxmlformats.org/presentationml/2006/main" showMasterSp="0" showMasterPhAnim="0">
   <p:cSld>
     <p:spTree>
@@ -1106,6 +1002,110 @@
       <p:sp>
         <p:nvSpPr>
           <p:cNvPr id="138" name="Google Shape;138;g3fb085bff3c_0_51:notes"/>
+          <p:cNvSpPr txBox="1">
+            <a:spLocks noGrp="1"/>
+          </p:cNvSpPr>
+          <p:nvPr>
+            <p:ph type="body" idx="1"/>
+          </p:nvPr>
+        </p:nvSpPr>
+        <p:spPr>
+          <a:xfrm>
+            <a:off x="685800" y="4343400"/>
+            <a:ext cx="5486400" cy="4114800"/>
+          </a:xfrm>
+          <a:prstGeom prst="rect">
+            <a:avLst/>
+          </a:prstGeom>
+        </p:spPr>
+        <p:txBody>
+          <a:bodyPr spcFirstLastPara="1" wrap="square" lIns="91425" tIns="91425" rIns="91425" bIns="91425" anchor="t" anchorCtr="0">
+            <a:noAutofit/>
+          </a:bodyPr>
+          <a:lstStyle/>
+          <a:p>
+            <a:pPr marL="0" lvl="0" indent="0" algn="l" rtl="0">
+              <a:spcBef>
+                <a:spcPts val="0"/>
+              </a:spcBef>
+              <a:spcAft>
+                <a:spcPts val="0"/>
+              </a:spcAft>
+              <a:buNone/>
+            </a:pPr>
+            <a:endParaRPr/>
+          </a:p>
+        </p:txBody>
+      </p:sp>
+    </p:spTree>
+  </p:cSld>
+  <p:clrMapOvr>
+    <a:masterClrMapping/>
+  </p:clrMapOvr>
+</p:notes>
+</file>
+
+<file path=ppt/notesSlides/notesSlide12.xml><?xml version="1.0" encoding="utf-8"?>
+<p:notes xmlns:a="http://schemas.openxmlformats.org/drawingml/2006/main" xmlns:r="http://schemas.openxmlformats.org/officeDocument/2006/relationships" xmlns:p="http://schemas.openxmlformats.org/presentationml/2006/main" showMasterSp="0" showMasterPhAnim="0">
+  <p:cSld>
+    <p:spTree>
+      <p:nvGrpSpPr>
+        <p:cNvPr id="1" name="Shape 144"/>
+        <p:cNvGrpSpPr/>
+        <p:nvPr/>
+      </p:nvGrpSpPr>
+      <p:grpSpPr>
+        <a:xfrm>
+          <a:off x="0" y="0"/>
+          <a:ext cx="0" cy="0"/>
+          <a:chOff x="0" y="0"/>
+          <a:chExt cx="0" cy="0"/>
+        </a:xfrm>
+      </p:grpSpPr>
+      <p:sp>
+        <p:nvSpPr>
+          <p:cNvPr id="145" name="Google Shape;145;g3fb085bff3c_0_56:notes"/>
+          <p:cNvSpPr>
+            <a:spLocks noGrp="1" noRot="1" noChangeAspect="1"/>
+          </p:cNvSpPr>
+          <p:nvPr>
+            <p:ph type="sldImg" idx="2"/>
+          </p:nvPr>
+        </p:nvSpPr>
+        <p:spPr>
+          <a:xfrm>
+            <a:off x="381000" y="685800"/>
+            <a:ext cx="6096000" cy="3429000"/>
+          </a:xfrm>
+          <a:custGeom>
+            <a:avLst/>
+            <a:gdLst/>
+            <a:ahLst/>
+            <a:cxnLst/>
+            <a:rect l="l" t="t" r="r" b="b"/>
+            <a:pathLst>
+              <a:path w="120000" h="120000" extrusionOk="0">
+                <a:moveTo>
+                  <a:pt x="0" y="0"/>
+                </a:moveTo>
+                <a:lnTo>
+                  <a:pt x="120000" y="0"/>
+                </a:lnTo>
+                <a:lnTo>
+                  <a:pt x="120000" y="120000"/>
+                </a:lnTo>
+                <a:lnTo>
+                  <a:pt x="0" y="120000"/>
+                </a:lnTo>
+                <a:close/>
+              </a:path>
+            </a:pathLst>
+          </a:custGeom>
+        </p:spPr>
+      </p:sp>
+      <p:sp>
+        <p:nvSpPr>
+          <p:cNvPr id="146" name="Google Shape;146;g3fb085bff3c_0_56:notes"/>
           <p:cNvSpPr txBox="1">
             <a:spLocks noGrp="1"/>
           </p:cNvSpPr>
@@ -1570,7 +1570,7 @@
   <p:cSld>
     <p:spTree>
       <p:nvGrpSpPr>
-        <p:cNvPr id="1" name="Shape 57"/>
+        <p:cNvPr id="1" name="Shape 65"/>
         <p:cNvGrpSpPr/>
         <p:nvPr/>
       </p:nvGrpSpPr>
@@ -1584,7 +1584,7 @@
       </p:grpSpPr>
       <p:sp>
         <p:nvSpPr>
-          <p:cNvPr id="58" name="Google Shape;58;g3fb085bff3c_0_134:notes"/>
+          <p:cNvPr id="66" name="Google Shape;66;g3fb085bff3c_0_4:notes"/>
           <p:cNvSpPr>
             <a:spLocks noGrp="1" noRot="1" noChangeAspect="1"/>
           </p:cNvSpPr>
@@ -1625,7 +1625,7 @@
       </p:sp>
       <p:sp>
         <p:nvSpPr>
-          <p:cNvPr id="59" name="Google Shape;59;g3fb085bff3c_0_134:notes"/>
+          <p:cNvPr id="67" name="Google Shape;67;g3fb085bff3c_0_4:notes"/>
           <p:cNvSpPr txBox="1">
             <a:spLocks noGrp="1"/>
           </p:cNvSpPr>
@@ -1670,110 +1670,6 @@
 </file>
 
 <file path=ppt/notesSlides/notesSlide3.xml><?xml version="1.0" encoding="utf-8"?>
-<p:notes xmlns:a="http://schemas.openxmlformats.org/drawingml/2006/main" xmlns:r="http://schemas.openxmlformats.org/officeDocument/2006/relationships" xmlns:p="http://schemas.openxmlformats.org/presentationml/2006/main" showMasterSp="0" showMasterPhAnim="0">
-  <p:cSld>
-    <p:spTree>
-      <p:nvGrpSpPr>
-        <p:cNvPr id="1" name="Shape 65"/>
-        <p:cNvGrpSpPr/>
-        <p:nvPr/>
-      </p:nvGrpSpPr>
-      <p:grpSpPr>
-        <a:xfrm>
-          <a:off x="0" y="0"/>
-          <a:ext cx="0" cy="0"/>
-          <a:chOff x="0" y="0"/>
-          <a:chExt cx="0" cy="0"/>
-        </a:xfrm>
-      </p:grpSpPr>
-      <p:sp>
-        <p:nvSpPr>
-          <p:cNvPr id="66" name="Google Shape;66;g3fb085bff3c_0_4:notes"/>
-          <p:cNvSpPr>
-            <a:spLocks noGrp="1" noRot="1" noChangeAspect="1"/>
-          </p:cNvSpPr>
-          <p:nvPr>
-            <p:ph type="sldImg" idx="2"/>
-          </p:nvPr>
-        </p:nvSpPr>
-        <p:spPr>
-          <a:xfrm>
-            <a:off x="381300" y="685800"/>
-            <a:ext cx="6096000" cy="3429000"/>
-          </a:xfrm>
-          <a:custGeom>
-            <a:avLst/>
-            <a:gdLst/>
-            <a:ahLst/>
-            <a:cxnLst/>
-            <a:rect l="l" t="t" r="r" b="b"/>
-            <a:pathLst>
-              <a:path w="120000" h="120000" extrusionOk="0">
-                <a:moveTo>
-                  <a:pt x="0" y="0"/>
-                </a:moveTo>
-                <a:lnTo>
-                  <a:pt x="120000" y="0"/>
-                </a:lnTo>
-                <a:lnTo>
-                  <a:pt x="120000" y="120000"/>
-                </a:lnTo>
-                <a:lnTo>
-                  <a:pt x="0" y="120000"/>
-                </a:lnTo>
-                <a:close/>
-              </a:path>
-            </a:pathLst>
-          </a:custGeom>
-        </p:spPr>
-      </p:sp>
-      <p:sp>
-        <p:nvSpPr>
-          <p:cNvPr id="67" name="Google Shape;67;g3fb085bff3c_0_4:notes"/>
-          <p:cNvSpPr txBox="1">
-            <a:spLocks noGrp="1"/>
-          </p:cNvSpPr>
-          <p:nvPr>
-            <p:ph type="body" idx="1"/>
-          </p:nvPr>
-        </p:nvSpPr>
-        <p:spPr>
-          <a:xfrm>
-            <a:off x="685800" y="4343400"/>
-            <a:ext cx="5486400" cy="4114800"/>
-          </a:xfrm>
-          <a:prstGeom prst="rect">
-            <a:avLst/>
-          </a:prstGeom>
-        </p:spPr>
-        <p:txBody>
-          <a:bodyPr spcFirstLastPara="1" wrap="square" lIns="91425" tIns="91425" rIns="91425" bIns="91425" anchor="t" anchorCtr="0">
-            <a:noAutofit/>
-          </a:bodyPr>
-          <a:lstStyle/>
-          <a:p>
-            <a:pPr marL="0" lvl="0" indent="0" algn="l" rtl="0">
-              <a:spcBef>
-                <a:spcPts val="0"/>
-              </a:spcBef>
-              <a:spcAft>
-                <a:spcPts val="0"/>
-              </a:spcAft>
-              <a:buNone/>
-            </a:pPr>
-            <a:endParaRPr/>
-          </a:p>
-        </p:txBody>
-      </p:sp>
-    </p:spTree>
-  </p:cSld>
-  <p:clrMapOvr>
-    <a:masterClrMapping/>
-  </p:clrMapOvr>
-</p:notes>
-</file>
-
-<file path=ppt/notesSlides/notesSlide4.xml><?xml version="1.0" encoding="utf-8"?>
 <p:notes xmlns:a="http://schemas.openxmlformats.org/drawingml/2006/main" xmlns:r="http://schemas.openxmlformats.org/officeDocument/2006/relationships" xmlns:p="http://schemas.openxmlformats.org/presentationml/2006/main" showMasterSp="0" showMasterPhAnim="0">
   <p:cSld>
     <p:spTree>
@@ -1877,7 +1773,7 @@
 </p:notes>
 </file>
 
-<file path=ppt/notesSlides/notesSlide5.xml><?xml version="1.0" encoding="utf-8"?>
+<file path=ppt/notesSlides/notesSlide4.xml><?xml version="1.0" encoding="utf-8"?>
 <p:notes xmlns:a="http://schemas.openxmlformats.org/drawingml/2006/main" xmlns:r="http://schemas.openxmlformats.org/officeDocument/2006/relationships" xmlns:p="http://schemas.openxmlformats.org/presentationml/2006/main" showMasterSp="0" showMasterPhAnim="0">
   <p:cSld>
     <p:spTree>
@@ -1981,7 +1877,7 @@
 </p:notes>
 </file>
 
-<file path=ppt/notesSlides/notesSlide6.xml><?xml version="1.0" encoding="utf-8"?>
+<file path=ppt/notesSlides/notesSlide5.xml><?xml version="1.0" encoding="utf-8"?>
 <p:notes xmlns:a="http://schemas.openxmlformats.org/drawingml/2006/main" xmlns:r="http://schemas.openxmlformats.org/officeDocument/2006/relationships" xmlns:p="http://schemas.openxmlformats.org/presentationml/2006/main" showMasterSp="0" showMasterPhAnim="0">
   <p:cSld>
     <p:spTree>
@@ -2010,7 +1906,7 @@
         </p:nvSpPr>
         <p:spPr>
           <a:xfrm>
-            <a:off x="381300" y="685800"/>
+            <a:off x="381000" y="685800"/>
             <a:ext cx="6096000" cy="3429000"/>
           </a:xfrm>
           <a:custGeom>
@@ -2085,7 +1981,7 @@
 </p:notes>
 </file>
 
-<file path=ppt/notesSlides/notesSlide7.xml><?xml version="1.0" encoding="utf-8"?>
+<file path=ppt/notesSlides/notesSlide6.xml><?xml version="1.0" encoding="utf-8"?>
 <p:notes xmlns:a="http://schemas.openxmlformats.org/drawingml/2006/main" xmlns:r="http://schemas.openxmlformats.org/officeDocument/2006/relationships" xmlns:p="http://schemas.openxmlformats.org/presentationml/2006/main" showMasterSp="0" showMasterPhAnim="0">
   <p:cSld>
     <p:spTree>
@@ -2189,7 +2085,7 @@
 </p:notes>
 </file>
 
-<file path=ppt/notesSlides/notesSlide8.xml><?xml version="1.0" encoding="utf-8"?>
+<file path=ppt/notesSlides/notesSlide7.xml><?xml version="1.0" encoding="utf-8"?>
 <p:notes xmlns:a="http://schemas.openxmlformats.org/drawingml/2006/main" xmlns:r="http://schemas.openxmlformats.org/officeDocument/2006/relationships" xmlns:p="http://schemas.openxmlformats.org/presentationml/2006/main" showMasterSp="0" showMasterPhAnim="0">
   <p:cSld>
     <p:spTree>
@@ -2218,7 +2114,7 @@
         </p:nvSpPr>
         <p:spPr>
           <a:xfrm>
-            <a:off x="381300" y="685800"/>
+            <a:off x="381000" y="685800"/>
             <a:ext cx="6096000" cy="3429000"/>
           </a:xfrm>
           <a:custGeom>
@@ -2293,7 +2189,7 @@
 </p:notes>
 </file>
 
-<file path=ppt/notesSlides/notesSlide9.xml><?xml version="1.0" encoding="utf-8"?>
+<file path=ppt/notesSlides/notesSlide8.xml><?xml version="1.0" encoding="utf-8"?>
 <p:notes xmlns:a="http://schemas.openxmlformats.org/drawingml/2006/main" xmlns:r="http://schemas.openxmlformats.org/officeDocument/2006/relationships" xmlns:p="http://schemas.openxmlformats.org/presentationml/2006/main" showMasterSp="0" showMasterPhAnim="0">
   <p:cSld>
     <p:spTree>
@@ -2354,6 +2250,110 @@
       <p:sp>
         <p:nvSpPr>
           <p:cNvPr id="114" name="Google Shape;114;g3fb085bff3c_0_36:notes"/>
+          <p:cNvSpPr txBox="1">
+            <a:spLocks noGrp="1"/>
+          </p:cNvSpPr>
+          <p:nvPr>
+            <p:ph type="body" idx="1"/>
+          </p:nvPr>
+        </p:nvSpPr>
+        <p:spPr>
+          <a:xfrm>
+            <a:off x="685800" y="4343400"/>
+            <a:ext cx="5486400" cy="4114800"/>
+          </a:xfrm>
+          <a:prstGeom prst="rect">
+            <a:avLst/>
+          </a:prstGeom>
+        </p:spPr>
+        <p:txBody>
+          <a:bodyPr spcFirstLastPara="1" wrap="square" lIns="91425" tIns="91425" rIns="91425" bIns="91425" anchor="t" anchorCtr="0">
+            <a:noAutofit/>
+          </a:bodyPr>
+          <a:lstStyle/>
+          <a:p>
+            <a:pPr marL="0" lvl="0" indent="0" algn="l" rtl="0">
+              <a:spcBef>
+                <a:spcPts val="0"/>
+              </a:spcBef>
+              <a:spcAft>
+                <a:spcPts val="0"/>
+              </a:spcAft>
+              <a:buNone/>
+            </a:pPr>
+            <a:endParaRPr/>
+          </a:p>
+        </p:txBody>
+      </p:sp>
+    </p:spTree>
+  </p:cSld>
+  <p:clrMapOvr>
+    <a:masterClrMapping/>
+  </p:clrMapOvr>
+</p:notes>
+</file>
+
+<file path=ppt/notesSlides/notesSlide9.xml><?xml version="1.0" encoding="utf-8"?>
+<p:notes xmlns:a="http://schemas.openxmlformats.org/drawingml/2006/main" xmlns:r="http://schemas.openxmlformats.org/officeDocument/2006/relationships" xmlns:p="http://schemas.openxmlformats.org/presentationml/2006/main" showMasterSp="0" showMasterPhAnim="0">
+  <p:cSld>
+    <p:spTree>
+      <p:nvGrpSpPr>
+        <p:cNvPr id="1" name="Shape 120"/>
+        <p:cNvGrpSpPr/>
+        <p:nvPr/>
+      </p:nvGrpSpPr>
+      <p:grpSpPr>
+        <a:xfrm>
+          <a:off x="0" y="0"/>
+          <a:ext cx="0" cy="0"/>
+          <a:chOff x="0" y="0"/>
+          <a:chExt cx="0" cy="0"/>
+        </a:xfrm>
+      </p:grpSpPr>
+      <p:sp>
+        <p:nvSpPr>
+          <p:cNvPr id="121" name="Google Shape;121;g3fb085bff3c_0_41:notes"/>
+          <p:cNvSpPr>
+            <a:spLocks noGrp="1" noRot="1" noChangeAspect="1"/>
+          </p:cNvSpPr>
+          <p:nvPr>
+            <p:ph type="sldImg" idx="2"/>
+          </p:nvPr>
+        </p:nvSpPr>
+        <p:spPr>
+          <a:xfrm>
+            <a:off x="381300" y="685800"/>
+            <a:ext cx="6096000" cy="3429000"/>
+          </a:xfrm>
+          <a:custGeom>
+            <a:avLst/>
+            <a:gdLst/>
+            <a:ahLst/>
+            <a:cxnLst/>
+            <a:rect l="l" t="t" r="r" b="b"/>
+            <a:pathLst>
+              <a:path w="120000" h="120000" extrusionOk="0">
+                <a:moveTo>
+                  <a:pt x="0" y="0"/>
+                </a:moveTo>
+                <a:lnTo>
+                  <a:pt x="120000" y="0"/>
+                </a:lnTo>
+                <a:lnTo>
+                  <a:pt x="120000" y="120000"/>
+                </a:lnTo>
+                <a:lnTo>
+                  <a:pt x="0" y="120000"/>
+                </a:lnTo>
+                <a:close/>
+              </a:path>
+            </a:pathLst>
+          </a:custGeom>
+        </p:spPr>
+      </p:sp>
+      <p:sp>
+        <p:nvSpPr>
+          <p:cNvPr id="122" name="Google Shape;122;g3fb085bff3c_0_41:notes"/>
           <p:cNvSpPr txBox="1">
             <a:spLocks noGrp="1"/>
           </p:cNvSpPr>
@@ -7334,299 +7334,6 @@
   <p:cSld>
     <p:spTree>
       <p:nvGrpSpPr>
-        <p:cNvPr id="1" name="Shape 123"/>
-        <p:cNvGrpSpPr/>
-        <p:nvPr/>
-      </p:nvGrpSpPr>
-      <p:grpSpPr>
-        <a:xfrm>
-          <a:off x="0" y="0"/>
-          <a:ext cx="0" cy="0"/>
-          <a:chOff x="0" y="0"/>
-          <a:chExt cx="0" cy="0"/>
-        </a:xfrm>
-      </p:grpSpPr>
-      <p:pic>
-        <p:nvPicPr>
-          <p:cNvPr id="124" name="Google Shape;124;p22" title="Frame 144.png"/>
-          <p:cNvPicPr preferRelativeResize="0"/>
-          <p:nvPr/>
-        </p:nvPicPr>
-        <p:blipFill rotWithShape="1">
-          <a:blip r:embed="rId3">
-            <a:alphaModFix/>
-          </a:blip>
-          <a:srcRect b="98001"/>
-          <a:stretch/>
-        </p:blipFill>
-        <p:spPr>
-          <a:xfrm>
-            <a:off x="0" y="5093562"/>
-            <a:ext cx="9144000" cy="54275"/>
-          </a:xfrm>
-          <a:prstGeom prst="rect">
-            <a:avLst/>
-          </a:prstGeom>
-          <a:noFill/>
-          <a:ln>
-            <a:noFill/>
-          </a:ln>
-        </p:spPr>
-      </p:pic>
-      <p:pic>
-        <p:nvPicPr>
-          <p:cNvPr id="125" name="Google Shape;125;p22" title="Group 427319979.png"/>
-          <p:cNvPicPr preferRelativeResize="0"/>
-          <p:nvPr/>
-        </p:nvPicPr>
-        <p:blipFill>
-          <a:blip r:embed="rId4">
-            <a:alphaModFix/>
-          </a:blip>
-          <a:stretch>
-            <a:fillRect/>
-          </a:stretch>
-        </p:blipFill>
-        <p:spPr>
-          <a:xfrm>
-            <a:off x="0" y="1"/>
-            <a:ext cx="9144000" cy="507359"/>
-          </a:xfrm>
-          <a:prstGeom prst="rect">
-            <a:avLst/>
-          </a:prstGeom>
-          <a:noFill/>
-          <a:ln>
-            <a:noFill/>
-          </a:ln>
-        </p:spPr>
-      </p:pic>
-      <p:sp>
-        <p:nvSpPr>
-          <p:cNvPr id="126" name="Google Shape;126;p22"/>
-          <p:cNvSpPr/>
-          <p:nvPr/>
-        </p:nvSpPr>
-        <p:spPr>
-          <a:xfrm>
-            <a:off x="-29250" y="5071875"/>
-            <a:ext cx="9173400" cy="97800"/>
-          </a:xfrm>
-          <a:prstGeom prst="rect">
-            <a:avLst/>
-          </a:prstGeom>
-          <a:solidFill>
-            <a:schemeClr val="dk1"/>
-          </a:solidFill>
-          <a:ln>
-            <a:noFill/>
-          </a:ln>
-        </p:spPr>
-        <p:txBody>
-          <a:bodyPr spcFirstLastPara="1" wrap="square" lIns="91425" tIns="91425" rIns="91425" bIns="91425" anchor="ctr" anchorCtr="0">
-            <a:noAutofit/>
-          </a:bodyPr>
-          <a:lstStyle/>
-          <a:p>
-            <a:pPr marL="0" lvl="0" indent="0" algn="ctr" rtl="0">
-              <a:spcBef>
-                <a:spcPts val="0"/>
-              </a:spcBef>
-              <a:spcAft>
-                <a:spcPts val="0"/>
-              </a:spcAft>
-              <a:buNone/>
-            </a:pPr>
-            <a:endParaRPr/>
-          </a:p>
-        </p:txBody>
-      </p:sp>
-      <p:sp>
-        <p:nvSpPr>
-          <p:cNvPr id="127" name="Google Shape;127;p22"/>
-          <p:cNvSpPr txBox="1"/>
-          <p:nvPr/>
-        </p:nvSpPr>
-        <p:spPr>
-          <a:xfrm>
-            <a:off x="265350" y="663825"/>
-            <a:ext cx="8943000" cy="561900"/>
-          </a:xfrm>
-          <a:prstGeom prst="rect">
-            <a:avLst/>
-          </a:prstGeom>
-          <a:noFill/>
-          <a:ln>
-            <a:noFill/>
-          </a:ln>
-        </p:spPr>
-        <p:txBody>
-          <a:bodyPr spcFirstLastPara="1" wrap="square" lIns="91425" tIns="91425" rIns="91425" bIns="91425" anchor="t" anchorCtr="0">
-            <a:noAutofit/>
-          </a:bodyPr>
-          <a:lstStyle/>
-          <a:p>
-            <a:pPr marL="0" lvl="0" indent="0" algn="l" rtl="0">
-              <a:lnSpc>
-                <a:spcPct val="115000"/>
-              </a:lnSpc>
-              <a:spcBef>
-                <a:spcPts val="0"/>
-              </a:spcBef>
-              <a:spcAft>
-                <a:spcPts val="0"/>
-              </a:spcAft>
-              <a:buNone/>
-            </a:pPr>
-            <a:r>
-              <a:rPr sz="1600">
-                <a:solidFill>
-                  <a:srgbClr val="212121"/>
-                </a:solidFill>
-                <a:latin typeface="Google Sans Flex Medium"/>
-              </a:rPr>
-              <a:t>Estimated implementation cost</a:t>
-            </a:r>
-            <a:endParaRPr sz="1600">
-              <a:latin typeface="Google Sans Flex Medium"/>
-              <a:ea typeface="Google Sans Flex Medium"/>
-              <a:cs typeface="Google Sans Flex Medium"/>
-              <a:sym typeface="Google Sans Flex Medium"/>
-            </a:endParaRPr>
-          </a:p>
-        </p:txBody>
-      </p:sp>
-      <p:sp>
-        <p:nvSpPr>
-          <p:cNvPr id="128" name="TextBox 127"/>
-          <p:cNvSpPr txBox="1"/>
-          <p:nvPr/>
-        </p:nvSpPr>
-        <p:spPr>
-          <a:xfrm>
-            <a:off x="265176" y="1280160"/>
-            <a:ext cx="8595360" cy="3566160"/>
-          </a:xfrm>
-          <a:prstGeom prst="rect">
-            <a:avLst/>
-          </a:prstGeom>
-          <a:noFill/>
-        </p:spPr>
-        <p:txBody>
-          <a:bodyPr wrap="square">
-            <a:spAutoFit/>
-          </a:bodyPr>
-          <a:lstStyle/>
-          <a:p>
-            <a:pPr>
-              <a:lnSpc>
-                <a:spcPct val="120000"/>
-              </a:lnSpc>
-              <a:spcAft>
-                <a:spcPts val="600"/>
-              </a:spcAft>
-            </a:pPr>
-            <a:r>
-              <a:rPr sz="1400">
-                <a:solidFill>
-                  <a:srgbClr val="212121"/>
-                </a:solidFill>
-                <a:latin typeface="Google Sans Flex"/>
-              </a:rPr>
-              <a:t>•  Current deployed cost: $0 — no billing account, no credit card, anywhere in the stack</a:t>
-            </a:r>
-          </a:p>
-          <a:p>
-            <a:pPr>
-              <a:lnSpc>
-                <a:spcPct val="120000"/>
-              </a:lnSpc>
-              <a:spcAft>
-                <a:spcPts val="600"/>
-              </a:spcAft>
-            </a:pPr>
-            <a:r>
-              <a:rPr sz="1400">
-                <a:solidFill>
-                  <a:srgbClr val="212121"/>
-                </a:solidFill>
-                <a:latin typeface="Google Sans Flex"/>
-              </a:rPr>
-              <a:t>•  Firebase Hosting: free Spark plan, no usage cap reached at this scale</a:t>
-            </a:r>
-          </a:p>
-          <a:p>
-            <a:pPr>
-              <a:lnSpc>
-                <a:spcPct val="120000"/>
-              </a:lnSpc>
-              <a:spcAft>
-                <a:spcPts val="600"/>
-              </a:spcAft>
-            </a:pPr>
-            <a:r>
-              <a:rPr sz="1400">
-                <a:solidFill>
-                  <a:srgbClr val="212121"/>
-                </a:solidFill>
-                <a:latin typeface="Google Sans Flex"/>
-              </a:rPr>
-              <a:t>•  Gemini API: free tier via Google AI Studio — 20 requests/day per project for gemini-3.8-flash; each diagnosis now uses 2 calls (diagnosis + orchestration), so roughly 10 full diagnoses/day before the app gracefully falls back to deterministic logic for the rest of the day</a:t>
-            </a:r>
-          </a:p>
-          <a:p>
-            <a:pPr>
-              <a:lnSpc>
-                <a:spcPct val="120000"/>
-              </a:lnSpc>
-              <a:spcAft>
-                <a:spcPts val="600"/>
-              </a:spcAft>
-            </a:pPr>
-            <a:r>
-              <a:rPr sz="1400">
-                <a:solidFill>
-                  <a:srgbClr val="212121"/>
-                </a:solidFill>
-                <a:latin typeface="Google Sans Flex"/>
-              </a:rPr>
-              <a:t>•  Open-Meteo, Web Speech API: free, no quota observed in testing</a:t>
-            </a:r>
-          </a:p>
-          <a:p>
-            <a:pPr>
-              <a:lnSpc>
-                <a:spcPct val="120000"/>
-              </a:lnSpc>
-              <a:spcAft>
-                <a:spcPts val="600"/>
-              </a:spcAft>
-            </a:pPr>
-            <a:r>
-              <a:rPr sz="1400">
-                <a:solidFill>
-                  <a:srgbClr val="212121"/>
-                </a:solidFill>
-                <a:latin typeface="Google Sans Flex"/>
-              </a:rPr>
-              <a:t>•  Scaling beyond the free tier: upgrading to a paid Gemini tier is the only cost that would be needed to raise the daily diagnosis cap — no other paid service is required even at higher usage, since there is no backend, database, or search service to scale</a:t>
-            </a:r>
-          </a:p>
-        </p:txBody>
-      </p:sp>
-    </p:spTree>
-  </p:cSld>
-  <p:clrMapOvr>
-    <a:masterClrMapping/>
-  </p:clrMapOvr>
-</p:sld>
-</file>
-
-<file path=ppt/slides/slide11.xml><?xml version="1.0" encoding="utf-8"?>
-<p:sld xmlns:a="http://schemas.openxmlformats.org/drawingml/2006/main" xmlns:r="http://schemas.openxmlformats.org/officeDocument/2006/relationships" xmlns:p="http://schemas.openxmlformats.org/presentationml/2006/main">
-  <p:cSld>
-    <p:spTree>
-      <p:nvGrpSpPr>
         <p:cNvPr id="1" name="Shape 131"/>
         <p:cNvGrpSpPr/>
         <p:nvPr/>
@@ -7845,7 +7552,7 @@
 </p:sld>
 </file>
 
-<file path=ppt/slides/slide12.xml><?xml version="1.0" encoding="utf-8"?>
+<file path=ppt/slides/slide11.xml><?xml version="1.0" encoding="utf-8"?>
 <p:sld xmlns:a="http://schemas.openxmlformats.org/drawingml/2006/main" xmlns:r="http://schemas.openxmlformats.org/officeDocument/2006/relationships" xmlns:p="http://schemas.openxmlformats.org/presentationml/2006/main">
   <p:cSld>
     <p:spTree>
@@ -8195,7 +7902,7 @@
 </p:sld>
 </file>
 
-<file path=ppt/slides/slide13.xml><?xml version="1.0" encoding="utf-8"?>
+<file path=ppt/slides/slide12.xml><?xml version="1.0" encoding="utf-8"?>
 <p:sld xmlns:a="http://schemas.openxmlformats.org/drawingml/2006/main" xmlns:r="http://schemas.openxmlformats.org/officeDocument/2006/relationships" xmlns:p="http://schemas.openxmlformats.org/presentationml/2006/main">
   <p:cSld>
     <p:spTree>
@@ -8462,6 +8169,285 @@
         </p:txBody>
       </p:sp>
     </p:spTree>
+  </p:cSld>
+  <p:clrMapOvr>
+    <a:masterClrMapping/>
+  </p:clrMapOvr>
+</p:sld>
+</file>
+
+<file path=ppt/slides/slide13.xml><?xml version="1.0" encoding="utf-8"?>
+<p:sld xmlns:a="http://schemas.openxmlformats.org/drawingml/2006/main" xmlns:r="http://schemas.openxmlformats.org/officeDocument/2006/relationships" xmlns:p="http://schemas.openxmlformats.org/presentationml/2006/main" show="0">
+  <p:cSld>
+    <p:spTree>
+      <p:nvGrpSpPr>
+        <p:cNvPr id="1" name="Shape 147"/>
+        <p:cNvGrpSpPr/>
+        <p:nvPr/>
+      </p:nvGrpSpPr>
+      <p:grpSpPr>
+        <a:xfrm>
+          <a:off x="0" y="0"/>
+          <a:ext cx="0" cy="0"/>
+          <a:chOff x="0" y="0"/>
+          <a:chExt cx="0" cy="0"/>
+        </a:xfrm>
+      </p:grpSpPr>
+      <p:pic>
+        <p:nvPicPr>
+          <p:cNvPr id="148" name="Google Shape;148;p25" title="Frame 144.png"/>
+          <p:cNvPicPr preferRelativeResize="0"/>
+          <p:nvPr/>
+        </p:nvPicPr>
+        <p:blipFill rotWithShape="1">
+          <a:blip r:embed="rId3">
+            <a:alphaModFix/>
+          </a:blip>
+          <a:srcRect b="98001"/>
+          <a:stretch/>
+        </p:blipFill>
+        <p:spPr>
+          <a:xfrm>
+            <a:off x="0" y="5093562"/>
+            <a:ext cx="9144000" cy="54275"/>
+          </a:xfrm>
+          <a:prstGeom prst="rect">
+            <a:avLst/>
+          </a:prstGeom>
+          <a:noFill/>
+          <a:ln>
+            <a:noFill/>
+          </a:ln>
+        </p:spPr>
+      </p:pic>
+      <p:pic>
+        <p:nvPicPr>
+          <p:cNvPr id="149" name="Google Shape;149;p25" title="Group 427319979.png"/>
+          <p:cNvPicPr preferRelativeResize="0"/>
+          <p:nvPr/>
+        </p:nvPicPr>
+        <p:blipFill>
+          <a:blip r:embed="rId4">
+            <a:alphaModFix/>
+          </a:blip>
+          <a:stretch>
+            <a:fillRect/>
+          </a:stretch>
+        </p:blipFill>
+        <p:spPr>
+          <a:xfrm>
+            <a:off x="0" y="1"/>
+            <a:ext cx="9144000" cy="507359"/>
+          </a:xfrm>
+          <a:prstGeom prst="rect">
+            <a:avLst/>
+          </a:prstGeom>
+          <a:noFill/>
+          <a:ln>
+            <a:noFill/>
+          </a:ln>
+        </p:spPr>
+      </p:pic>
+      <p:sp>
+        <p:nvSpPr>
+          <p:cNvPr id="150" name="Google Shape;150;p25"/>
+          <p:cNvSpPr/>
+          <p:nvPr/>
+        </p:nvSpPr>
+        <p:spPr>
+          <a:xfrm>
+            <a:off x="-29250" y="5071875"/>
+            <a:ext cx="9173400" cy="97800"/>
+          </a:xfrm>
+          <a:prstGeom prst="rect">
+            <a:avLst/>
+          </a:prstGeom>
+          <a:solidFill>
+            <a:schemeClr val="dk1"/>
+          </a:solidFill>
+          <a:ln>
+            <a:noFill/>
+          </a:ln>
+        </p:spPr>
+        <p:txBody>
+          <a:bodyPr spcFirstLastPara="1" wrap="square" lIns="91425" tIns="91425" rIns="91425" bIns="91425" anchor="ctr" anchorCtr="0">
+            <a:noAutofit/>
+          </a:bodyPr>
+          <a:lstStyle/>
+          <a:p>
+            <a:pPr marL="0" lvl="0" indent="0" algn="ctr" rtl="0">
+              <a:spcBef>
+                <a:spcPts val="0"/>
+              </a:spcBef>
+              <a:spcAft>
+                <a:spcPts val="0"/>
+              </a:spcAft>
+              <a:buNone/>
+            </a:pPr>
+            <a:endParaRPr/>
+          </a:p>
+        </p:txBody>
+      </p:sp>
+      <p:sp>
+        <p:nvSpPr>
+          <p:cNvPr id="151" name="Google Shape;151;p25"/>
+          <p:cNvSpPr txBox="1"/>
+          <p:nvPr/>
+        </p:nvSpPr>
+        <p:spPr>
+          <a:xfrm>
+            <a:off x="265350" y="663825"/>
+            <a:ext cx="8943000" cy="561900"/>
+          </a:xfrm>
+          <a:prstGeom prst="rect">
+            <a:avLst/>
+          </a:prstGeom>
+          <a:noFill/>
+          <a:ln>
+            <a:noFill/>
+          </a:ln>
+        </p:spPr>
+        <p:txBody>
+          <a:bodyPr spcFirstLastPara="1" wrap="square" lIns="91425" tIns="91425" rIns="91425" bIns="91425" anchor="t" anchorCtr="0">
+            <a:noAutofit/>
+          </a:bodyPr>
+          <a:lstStyle/>
+          <a:p>
+            <a:pPr marL="0" lvl="0" indent="0" algn="l" rtl="0">
+              <a:lnSpc>
+                <a:spcPct val="115000"/>
+              </a:lnSpc>
+              <a:spcBef>
+                <a:spcPts val="0"/>
+              </a:spcBef>
+              <a:spcAft>
+                <a:spcPts val="0"/>
+              </a:spcAft>
+              <a:buNone/>
+            </a:pPr>
+            <a:r>
+              <a:rPr sz="1600">
+                <a:solidFill>
+                  <a:srgbClr val="212121"/>
+                </a:solidFill>
+                <a:latin typeface="Google Sans Flex Medium"/>
+              </a:rPr>
+              <a:t>Additional Details / Future Development</a:t>
+            </a:r>
+            <a:endParaRPr sz="1600">
+              <a:latin typeface="Google Sans Flex Medium"/>
+              <a:ea typeface="Google Sans Flex Medium"/>
+              <a:cs typeface="Google Sans Flex Medium"/>
+              <a:sym typeface="Google Sans Flex Medium"/>
+            </a:endParaRPr>
+          </a:p>
+        </p:txBody>
+      </p:sp>
+      <p:sp>
+        <p:nvSpPr>
+          <p:cNvPr id="152" name="TextBox 151"/>
+          <p:cNvSpPr txBox="1"/>
+          <p:nvPr/>
+        </p:nvSpPr>
+        <p:spPr>
+          <a:xfrm>
+            <a:off x="265176" y="1280160"/>
+            <a:ext cx="8595360" cy="3948325"/>
+          </a:xfrm>
+          <a:prstGeom prst="rect">
+            <a:avLst/>
+          </a:prstGeom>
+          <a:noFill/>
+        </p:spPr>
+        <p:txBody>
+          <a:bodyPr wrap="square">
+            <a:spAutoFit/>
+          </a:bodyPr>
+          <a:lstStyle/>
+          <a:p>
+            <a:pPr>
+              <a:lnSpc>
+                <a:spcPct val="120000"/>
+              </a:lnSpc>
+              <a:spcAft>
+                <a:spcPts val="700"/>
+              </a:spcAft>
+            </a:pPr>
+            <a:r>
+              <a:rPr lang="en-US" sz="1300">
+                <a:solidFill>
+                  <a:srgbClr val="212121"/>
+                </a:solidFill>
+                <a:latin typeface="Google Sans Flex"/>
+              </a:rPr>
+              <a:t>•  Next step — upgrade to managed Google Cloud services once billing is available: Gemini moved behind a Cloud Run/Cloud Functions proxy (closes the current public-key exposure and removes the 20-req/day free-tier ceiling), Firestore replacing the static dealer/price/history JSON so the district dashboard becomes genuinely live instead of a deploy-time snapshot, Vertex AI Search replacing the hand-rolled TF-IDF retrieval, and Cloud Translation/Text-to-Speech replacing the template-based Kannada advisory. Every substitute today sits behind one isolated call site per module, so each swap is incremental, not a rewrite.</a:t>
+            </a:r>
+          </a:p>
+          <a:p>
+            <a:pPr>
+              <a:lnSpc>
+                <a:spcPct val="120000"/>
+              </a:lnSpc>
+              <a:spcAft>
+                <a:spcPts val="700"/>
+              </a:spcAft>
+            </a:pPr>
+            <a:r>
+              <a:rPr lang="en-US" sz="1300">
+                <a:solidFill>
+                  <a:srgbClr val="212121"/>
+                </a:solidFill>
+                <a:latin typeface="Google Sans Flex"/>
+              </a:rPr>
+              <a:t>•  Offline-first fallback (planned): a distilled on-device TensorFlow Lite classifier for the 8–10 most common regional diseases, so core diagnosis keeps working when connectivity drops entirely. Training script already written, pending a real multi-hour training run on the full PlantVillage dataset.</a:t>
+            </a:r>
+          </a:p>
+          <a:p>
+            <a:pPr>
+              <a:lnSpc>
+                <a:spcPct val="120000"/>
+              </a:lnSpc>
+              <a:spcAft>
+                <a:spcPts val="700"/>
+              </a:spcAft>
+            </a:pPr>
+            <a:r>
+              <a:rPr lang="en-US" sz="1300">
+                <a:solidFill>
+                  <a:srgbClr val="212121"/>
+                </a:solidFill>
+                <a:latin typeface="Google Sans Flex"/>
+              </a:rPr>
+              <a:t>•  Expansion path: adding a new crop or region means indexing a new disease guide into the retrieval layer, not rewriting the diagnosis logic — the architecture is crop-agnostic by design even though this build is scoped to tomato in Karnataka for the demo.</a:t>
+            </a:r>
+          </a:p>
+          <a:p>
+            <a:pPr>
+              <a:lnSpc>
+                <a:spcPct val="120000"/>
+              </a:lnSpc>
+              <a:spcAft>
+                <a:spcPts val="700"/>
+              </a:spcAft>
+            </a:pPr>
+            <a:r>
+              <a:rPr lang="en-US" sz="1300">
+                <a:solidFill>
+                  <a:srgbClr val="212121"/>
+                </a:solidFill>
+                <a:latin typeface="Google Sans Flex"/>
+              </a:rPr>
+              <a:t>•  Resource &amp; environmental impact: targeted treatment instead of blanket spraying, weather-timed application to reduce chemical runoff, and earlier detection to reduce crop loss — moving this beyond social impact into genuine sustainability.</a:t>
+            </a:r>
+          </a:p>
+        </p:txBody>
+      </p:sp>
+    </p:spTree>
+    <p:extLst>
+      <p:ext uri="{BB962C8B-B14F-4D97-AF65-F5344CB8AC3E}">
+        <p14:creationId xmlns:p14="http://schemas.microsoft.com/office/powerpoint/2010/main" val="773534487"/>
+      </p:ext>
+    </p:extLst>
   </p:cSld>
   <p:clrMapOvr>
     <a:masterClrMapping/>
@@ -8897,257 +8883,6 @@
   <p:cSld>
     <p:spTree>
       <p:nvGrpSpPr>
-        <p:cNvPr id="1" name="Shape 60"/>
-        <p:cNvGrpSpPr/>
-        <p:nvPr/>
-      </p:nvGrpSpPr>
-      <p:grpSpPr>
-        <a:xfrm>
-          <a:off x="0" y="0"/>
-          <a:ext cx="0" cy="0"/>
-          <a:chOff x="0" y="0"/>
-          <a:chExt cx="0" cy="0"/>
-        </a:xfrm>
-      </p:grpSpPr>
-      <p:pic>
-        <p:nvPicPr>
-          <p:cNvPr id="61" name="Google Shape;61;p14" title="Frame 144.png"/>
-          <p:cNvPicPr preferRelativeResize="0"/>
-          <p:nvPr/>
-        </p:nvPicPr>
-        <p:blipFill rotWithShape="1">
-          <a:blip r:embed="rId3">
-            <a:alphaModFix/>
-          </a:blip>
-          <a:srcRect b="98001"/>
-          <a:stretch/>
-        </p:blipFill>
-        <p:spPr>
-          <a:xfrm>
-            <a:off x="0" y="5093562"/>
-            <a:ext cx="9144000" cy="54275"/>
-          </a:xfrm>
-          <a:prstGeom prst="rect">
-            <a:avLst/>
-          </a:prstGeom>
-          <a:noFill/>
-          <a:ln>
-            <a:noFill/>
-          </a:ln>
-        </p:spPr>
-      </p:pic>
-      <p:sp>
-        <p:nvSpPr>
-          <p:cNvPr id="62" name="Google Shape;62;p14"/>
-          <p:cNvSpPr/>
-          <p:nvPr/>
-        </p:nvSpPr>
-        <p:spPr>
-          <a:xfrm>
-            <a:off x="0" y="0"/>
-            <a:ext cx="9144000" cy="5143500"/>
-          </a:xfrm>
-          <a:prstGeom prst="rect">
-            <a:avLst/>
-          </a:prstGeom>
-          <a:solidFill>
-            <a:schemeClr val="dk1"/>
-          </a:solidFill>
-          <a:ln>
-            <a:noFill/>
-          </a:ln>
-        </p:spPr>
-        <p:txBody>
-          <a:bodyPr spcFirstLastPara="1" wrap="square" lIns="91425" tIns="91425" rIns="91425" bIns="91425" anchor="ctr" anchorCtr="0">
-            <a:noAutofit/>
-          </a:bodyPr>
-          <a:lstStyle/>
-          <a:p>
-            <a:pPr marL="0" lvl="0" indent="0" algn="ctr" rtl="0">
-              <a:spcBef>
-                <a:spcPts val="0"/>
-              </a:spcBef>
-              <a:spcAft>
-                <a:spcPts val="0"/>
-              </a:spcAft>
-              <a:buNone/>
-            </a:pPr>
-            <a:endParaRPr/>
-          </a:p>
-        </p:txBody>
-      </p:sp>
-      <p:sp>
-        <p:nvSpPr>
-          <p:cNvPr id="63" name="Google Shape;63;p14"/>
-          <p:cNvSpPr txBox="1"/>
-          <p:nvPr/>
-        </p:nvSpPr>
-        <p:spPr>
-          <a:xfrm>
-            <a:off x="5092475" y="1968750"/>
-            <a:ext cx="3311400" cy="1206000"/>
-          </a:xfrm>
-          <a:prstGeom prst="rect">
-            <a:avLst/>
-          </a:prstGeom>
-          <a:noFill/>
-          <a:ln>
-            <a:noFill/>
-          </a:ln>
-        </p:spPr>
-        <p:txBody>
-          <a:bodyPr spcFirstLastPara="1" wrap="square" lIns="91425" tIns="91425" rIns="91425" bIns="91425" anchor="t" anchorCtr="0">
-            <a:noAutofit/>
-          </a:bodyPr>
-          <a:lstStyle/>
-          <a:p>
-            <a:pPr marL="0" lvl="0" indent="0" algn="l" rtl="0">
-              <a:spcBef>
-                <a:spcPts val="0"/>
-              </a:spcBef>
-              <a:spcAft>
-                <a:spcPts val="0"/>
-              </a:spcAft>
-              <a:buNone/>
-            </a:pPr>
-            <a:r>
-              <a:rPr lang="en-GB" sz="1100">
-                <a:solidFill>
-                  <a:schemeClr val="lt1"/>
-                </a:solidFill>
-                <a:latin typeface="Google Sans Flex Medium"/>
-                <a:ea typeface="Google Sans Flex Medium"/>
-                <a:cs typeface="Google Sans Flex Medium"/>
-                <a:sym typeface="Google Sans Flex Medium"/>
-              </a:rPr>
-              <a:t>Note:</a:t>
-            </a:r>
-            <a:r>
-              <a:rPr lang="en-GB" sz="1100">
-                <a:solidFill>
-                  <a:schemeClr val="lt1"/>
-                </a:solidFill>
-                <a:latin typeface="Google Sans Flex"/>
-                <a:ea typeface="Google Sans Flex"/>
-                <a:cs typeface="Google Sans Flex"/>
-                <a:sym typeface="Google Sans Flex"/>
-              </a:rPr>
-              <a:t> Please download this template to make your edits and submit the final version.</a:t>
-            </a:r>
-            <a:br>
-              <a:rPr lang="en-GB" sz="1100">
-                <a:solidFill>
-                  <a:schemeClr val="lt1"/>
-                </a:solidFill>
-                <a:latin typeface="Google Sans Flex"/>
-                <a:ea typeface="Google Sans Flex"/>
-                <a:cs typeface="Google Sans Flex"/>
-                <a:sym typeface="Google Sans Flex"/>
-              </a:rPr>
-            </a:br>
-            <a:br>
-              <a:rPr lang="en-GB" sz="1100">
-                <a:solidFill>
-                  <a:schemeClr val="lt1"/>
-                </a:solidFill>
-                <a:latin typeface="Google Sans Flex"/>
-                <a:ea typeface="Google Sans Flex"/>
-                <a:cs typeface="Google Sans Flex"/>
-                <a:sym typeface="Google Sans Flex"/>
-              </a:rPr>
-            </a:br>
-            <a:r>
-              <a:rPr lang="en-GB" sz="1100">
-                <a:solidFill>
-                  <a:schemeClr val="lt1"/>
-                </a:solidFill>
-                <a:latin typeface="Google Sans Flex"/>
-                <a:ea typeface="Google Sans Flex"/>
-                <a:cs typeface="Google Sans Flex"/>
-                <a:sym typeface="Google Sans Flex"/>
-              </a:rPr>
-              <a:t>To download, go to File &gt; Download &gt; Microsoft PowerPoint (.PPTX). Kindly refrain from sending edit requests.</a:t>
-            </a:r>
-            <a:endParaRPr sz="1100">
-              <a:solidFill>
-                <a:schemeClr val="lt1"/>
-              </a:solidFill>
-              <a:latin typeface="Google Sans Flex"/>
-              <a:ea typeface="Google Sans Flex"/>
-              <a:cs typeface="Google Sans Flex"/>
-              <a:sym typeface="Google Sans Flex"/>
-            </a:endParaRPr>
-          </a:p>
-          <a:p>
-            <a:pPr marL="0" lvl="0" indent="0" algn="l" rtl="0">
-              <a:spcBef>
-                <a:spcPts val="0"/>
-              </a:spcBef>
-              <a:spcAft>
-                <a:spcPts val="0"/>
-              </a:spcAft>
-              <a:buNone/>
-            </a:pPr>
-            <a:endParaRPr sz="1100">
-              <a:solidFill>
-                <a:schemeClr val="lt1"/>
-              </a:solidFill>
-              <a:latin typeface="Google Sans Flex"/>
-              <a:ea typeface="Google Sans Flex"/>
-              <a:cs typeface="Google Sans Flex"/>
-              <a:sym typeface="Google Sans Flex"/>
-            </a:endParaRPr>
-          </a:p>
-        </p:txBody>
-      </p:sp>
-      <p:pic>
-        <p:nvPicPr>
-          <p:cNvPr id="64" name="Google Shape;64;p14"/>
-          <p:cNvPicPr preferRelativeResize="0"/>
-          <p:nvPr/>
-        </p:nvPicPr>
-        <p:blipFill>
-          <a:blip r:embed="rId4">
-            <a:alphaModFix/>
-          </a:blip>
-          <a:stretch>
-            <a:fillRect/>
-          </a:stretch>
-        </p:blipFill>
-        <p:spPr>
-          <a:xfrm>
-            <a:off x="924203" y="1194675"/>
-            <a:ext cx="3604250" cy="2621725"/>
-          </a:xfrm>
-          <a:prstGeom prst="rect">
-            <a:avLst/>
-          </a:prstGeom>
-          <a:noFill/>
-          <a:ln>
-            <a:noFill/>
-          </a:ln>
-          <a:effectLst>
-            <a:outerShdw blurRad="971550" dist="19050" dir="5400000" algn="bl" rotWithShape="0">
-              <a:schemeClr val="lt1">
-                <a:alpha val="50000"/>
-              </a:schemeClr>
-            </a:outerShdw>
-          </a:effectLst>
-        </p:spPr>
-      </p:pic>
-    </p:spTree>
-  </p:cSld>
-  <p:clrMapOvr>
-    <a:masterClrMapping/>
-  </p:clrMapOvr>
-</p:sld>
-</file>
-
-<file path=ppt/slides/slide3.xml><?xml version="1.0" encoding="utf-8"?>
-<p:sld xmlns:a="http://schemas.openxmlformats.org/drawingml/2006/main" xmlns:r="http://schemas.openxmlformats.org/officeDocument/2006/relationships" xmlns:p="http://schemas.openxmlformats.org/presentationml/2006/main">
-  <p:cSld>
-    <p:spTree>
-      <p:nvGrpSpPr>
         <p:cNvPr id="1" name="Shape 68"/>
         <p:cNvGrpSpPr/>
         <p:nvPr/>
@@ -9390,7 +9125,7 @@
 </p:sld>
 </file>
 
-<file path=ppt/slides/slide4.xml><?xml version="1.0" encoding="utf-8"?>
+<file path=ppt/slides/slide3.xml><?xml version="1.0" encoding="utf-8"?>
 <p:sld xmlns:a="http://schemas.openxmlformats.org/drawingml/2006/main" xmlns:r="http://schemas.openxmlformats.org/officeDocument/2006/relationships" xmlns:p="http://schemas.openxmlformats.org/presentationml/2006/main">
   <p:cSld>
     <p:spTree>
@@ -9645,7 +9380,7 @@
 </p:sld>
 </file>
 
-<file path=ppt/slides/slide5.xml><?xml version="1.0" encoding="utf-8"?>
+<file path=ppt/slides/slide4.xml><?xml version="1.0" encoding="utf-8"?>
 <p:sld xmlns:a="http://schemas.openxmlformats.org/drawingml/2006/main" xmlns:r="http://schemas.openxmlformats.org/officeDocument/2006/relationships" xmlns:p="http://schemas.openxmlformats.org/presentationml/2006/main">
   <p:cSld>
     <p:spTree>
@@ -10033,7 +9768,7 @@
 </p:sld>
 </file>
 
-<file path=ppt/slides/slide6.xml><?xml version="1.0" encoding="utf-8"?>
+<file path=ppt/slides/slide5.xml><?xml version="1.0" encoding="utf-8"?>
 <p:sld xmlns:a="http://schemas.openxmlformats.org/drawingml/2006/main" xmlns:r="http://schemas.openxmlformats.org/officeDocument/2006/relationships" xmlns:p="http://schemas.openxmlformats.org/presentationml/2006/main">
   <p:cSld>
     <p:spTree>
@@ -10202,14 +9937,166 @@
       </p:sp>
       <p:sp>
         <p:nvSpPr>
-          <p:cNvPr id="96" name="TextBox 95"/>
+          <p:cNvPr id="96" name="Rounded Rectangle 95"/>
+          <p:cNvSpPr>
+            <a:spLocks/>
+          </p:cNvSpPr>
+          <p:nvPr/>
+        </p:nvSpPr>
+        <p:spPr>
+          <a:xfrm>
+            <a:off x="201168" y="1298448"/>
+            <a:ext cx="4288536" cy="420624"/>
+          </a:xfrm>
+          <a:prstGeom prst="roundRect">
+            <a:avLst/>
+          </a:prstGeom>
+          <a:solidFill>
+            <a:srgbClr val="F1F1F1"/>
+          </a:solidFill>
+          <a:ln w="12700">
+            <a:solidFill>
+              <a:srgbClr val="B0B0B0"/>
+            </a:solidFill>
+          </a:ln>
+          <a:effectLst/>
+        </p:spPr>
+        <p:style>
+          <a:lnRef idx="1">
+            <a:schemeClr val="accent1"/>
+          </a:lnRef>
+          <a:fillRef idx="3">
+            <a:schemeClr val="accent1"/>
+          </a:fillRef>
+          <a:effectRef idx="2">
+            <a:schemeClr val="accent1"/>
+          </a:effectRef>
+          <a:fontRef idx="minor">
+            <a:schemeClr val="lt1"/>
+          </a:fontRef>
+        </p:style>
+        <p:txBody>
+          <a:bodyPr wrap="square" lIns="64008" tIns="18288" rIns="64008" bIns="18288" rtlCol="0" anchor="ctr"/>
+          <a:lstStyle/>
+          <a:p>
+            <a:pPr algn="ctr">
+              <a:lnSpc>
+                <a:spcPct val="100000"/>
+              </a:lnSpc>
+            </a:pPr>
+            <a:r>
+              <a:rPr lang="en-US" sz="1000" b="1">
+                <a:solidFill>
+                  <a:srgbClr val="212121"/>
+                </a:solidFill>
+                <a:latin typeface="Google Sans Flex SemiBold"/>
+              </a:rPr>
+              <a:t>FARMER INPUT</a:t>
+            </a:r>
+          </a:p>
+          <a:p>
+            <a:pPr algn="ctr">
+              <a:lnSpc>
+                <a:spcPct val="100000"/>
+              </a:lnSpc>
+            </a:pPr>
+            <a:r>
+              <a:rPr lang="en-US" sz="800" b="0">
+                <a:solidFill>
+                  <a:srgbClr val="595959"/>
+                </a:solidFill>
+                <a:latin typeface="Google Sans Flex"/>
+              </a:rPr>
+              <a:t>Symptom text or speech (Kannada/English) + optional photo, in-browser</a:t>
+            </a:r>
+          </a:p>
+        </p:txBody>
+      </p:sp>
+      <p:sp>
+        <p:nvSpPr>
+          <p:cNvPr id="97" name="Rounded Rectangle 96"/>
+          <p:cNvSpPr/>
+          <p:nvPr/>
+        </p:nvSpPr>
+        <p:spPr>
+          <a:xfrm>
+            <a:off x="4654295" y="1298448"/>
+            <a:ext cx="4288536" cy="420624"/>
+          </a:xfrm>
+          <a:prstGeom prst="roundRect">
+            <a:avLst/>
+          </a:prstGeom>
+          <a:solidFill>
+            <a:srgbClr val="F1F1F1"/>
+          </a:solidFill>
+          <a:ln w="12700">
+            <a:solidFill>
+              <a:srgbClr val="B0B0B0"/>
+            </a:solidFill>
+          </a:ln>
+          <a:effectLst/>
+        </p:spPr>
+        <p:style>
+          <a:lnRef idx="1">
+            <a:schemeClr val="accent1"/>
+          </a:lnRef>
+          <a:fillRef idx="3">
+            <a:schemeClr val="accent1"/>
+          </a:fillRef>
+          <a:effectRef idx="2">
+            <a:schemeClr val="accent1"/>
+          </a:effectRef>
+          <a:fontRef idx="minor">
+            <a:schemeClr val="lt1"/>
+          </a:fontRef>
+        </p:style>
+        <p:txBody>
+          <a:bodyPr wrap="square" lIns="64008" tIns="18288" rIns="64008" bIns="18288" rtlCol="0" anchor="ctr"/>
+          <a:lstStyle/>
+          <a:p>
+            <a:pPr algn="ctr">
+              <a:lnSpc>
+                <a:spcPct val="100000"/>
+              </a:lnSpc>
+            </a:pPr>
+            <a:r>
+              <a:rPr sz="1000" b="1">
+                <a:solidFill>
+                  <a:srgbClr val="212121"/>
+                </a:solidFill>
+                <a:latin typeface="Google Sans Flex SemiBold"/>
+              </a:rPr>
+              <a:t>CONTEXT CHECKS</a:t>
+            </a:r>
+          </a:p>
+          <a:p>
+            <a:pPr algn="ctr">
+              <a:lnSpc>
+                <a:spcPct val="100000"/>
+              </a:lnSpc>
+            </a:pPr>
+            <a:r>
+              <a:rPr sz="800" b="0">
+                <a:solidFill>
+                  <a:srgbClr val="595959"/>
+                </a:solidFill>
+                <a:latin typeface="Google Sans Flex"/>
+              </a:rPr>
+              <a:t>Weather (Open-Meteo), outbreak radius, plot-memory history</a:t>
+            </a:r>
+          </a:p>
+        </p:txBody>
+      </p:sp>
+      <p:sp>
+        <p:nvSpPr>
+          <p:cNvPr id="98" name="TextBox 97"/>
           <p:cNvSpPr txBox="1"/>
           <p:nvPr/>
         </p:nvSpPr>
         <p:spPr>
           <a:xfrm>
-            <a:off x="265176" y="1371600"/>
-            <a:ext cx="8595360" cy="3474720"/>
+            <a:off x="4434840" y="1719072"/>
+            <a:ext cx="274320" cy="146304"/>
           </a:xfrm>
           <a:prstGeom prst="rect">
             <a:avLst/>
@@ -10217,160 +10104,705 @@
           <a:noFill/>
         </p:spPr>
         <p:txBody>
-          <a:bodyPr wrap="square">
+          <a:bodyPr wrap="none" lIns="0" tIns="0" rIns="0" bIns="0">
             <a:spAutoFit/>
           </a:bodyPr>
           <a:lstStyle/>
           <a:p>
-            <a:pPr>
+            <a:pPr algn="ctr"/>
+            <a:r>
+              <a:rPr sz="1400" b="1">
+                <a:solidFill>
+                  <a:srgbClr val="B0B0B0"/>
+                </a:solidFill>
+              </a:rPr>
+              <a:t>↓</a:t>
+            </a:r>
+          </a:p>
+        </p:txBody>
+      </p:sp>
+      <p:sp>
+        <p:nvSpPr>
+          <p:cNvPr id="99" name="Rounded Rectangle 98"/>
+          <p:cNvSpPr/>
+          <p:nvPr/>
+        </p:nvSpPr>
+        <p:spPr>
+          <a:xfrm>
+            <a:off x="201168" y="1865376"/>
+            <a:ext cx="8741663" cy="420624"/>
+          </a:xfrm>
+          <a:prstGeom prst="roundRect">
+            <a:avLst/>
+          </a:prstGeom>
+          <a:solidFill>
+            <a:srgbClr val="E1F5FE"/>
+          </a:solidFill>
+          <a:ln w="12700">
+            <a:solidFill>
+              <a:srgbClr val="4FC3F7"/>
+            </a:solidFill>
+          </a:ln>
+          <a:effectLst/>
+        </p:spPr>
+        <p:style>
+          <a:lnRef idx="1">
+            <a:schemeClr val="accent1"/>
+          </a:lnRef>
+          <a:fillRef idx="3">
+            <a:schemeClr val="accent1"/>
+          </a:fillRef>
+          <a:effectRef idx="2">
+            <a:schemeClr val="accent1"/>
+          </a:effectRef>
+          <a:fontRef idx="minor">
+            <a:schemeClr val="lt1"/>
+          </a:fontRef>
+        </p:style>
+        <p:txBody>
+          <a:bodyPr wrap="square" lIns="64008" tIns="18288" rIns="64008" bIns="18288" rtlCol="0" anchor="ctr"/>
+          <a:lstStyle/>
+          <a:p>
+            <a:pPr algn="ctr">
               <a:lnSpc>
-                <a:spcPct val="120000"/>
+                <a:spcPct val="100000"/>
               </a:lnSpc>
-              <a:spcAft>
-                <a:spcPts val="600"/>
-              </a:spcAft>
             </a:pPr>
             <a:r>
-              <a:rPr sz="1250">
+              <a:rPr sz="1000" b="1">
                 <a:solidFill>
                   <a:srgbClr val="212121"/>
+                </a:solidFill>
+                <a:latin typeface="Google Sans Flex SemiBold"/>
+              </a:rPr>
+              <a:t>GEMINI CALL 1 — DIAGNOSIS</a:t>
+            </a:r>
+          </a:p>
+          <a:p>
+            <a:pPr algn="ctr">
+              <a:lnSpc>
+                <a:spcPct val="100000"/>
+              </a:lnSpc>
+            </a:pPr>
+            <a:r>
+              <a:rPr sz="800" b="0">
+                <a:solidFill>
+                  <a:srgbClr val="595959"/>
                 </a:solidFill>
                 <a:latin typeface="Google Sans Flex"/>
               </a:rPr>
-              <a:t>•  Farmer speaks/types symptom + optionally uploads a photo, entirely in the browser</a:t>
+              <a:t>Multimodal + RAG (TF-IDF over 18 bilingual disease docs) → structured diagnosis JSON</a:t>
             </a:r>
           </a:p>
-          <a:p>
-            <a:pPr>
+        </p:txBody>
+      </p:sp>
+      <p:sp>
+        <p:nvSpPr>
+          <p:cNvPr id="100" name="TextBox 99"/>
+          <p:cNvSpPr txBox="1"/>
+          <p:nvPr/>
+        </p:nvSpPr>
+        <p:spPr>
+          <a:xfrm>
+            <a:off x="4434840" y="2286000"/>
+            <a:ext cx="274320" cy="146304"/>
+          </a:xfrm>
+          <a:prstGeom prst="rect">
+            <a:avLst/>
+          </a:prstGeom>
+          <a:noFill/>
+        </p:spPr>
+        <p:txBody>
+          <a:bodyPr wrap="none" lIns="0" tIns="0" rIns="0" bIns="0">
+            <a:spAutoFit/>
+          </a:bodyPr>
+          <a:lstStyle/>
+          <a:p>
+            <a:pPr algn="ctr"/>
+            <a:r>
+              <a:rPr sz="1400" b="1">
+                <a:solidFill>
+                  <a:srgbClr val="B0B0B0"/>
+                </a:solidFill>
+              </a:rPr>
+              <a:t>↓</a:t>
+            </a:r>
+          </a:p>
+        </p:txBody>
+      </p:sp>
+      <p:sp>
+        <p:nvSpPr>
+          <p:cNvPr id="101" name="Rounded Rectangle 100"/>
+          <p:cNvSpPr/>
+          <p:nvPr/>
+        </p:nvSpPr>
+        <p:spPr>
+          <a:xfrm>
+            <a:off x="201168" y="2432304"/>
+            <a:ext cx="8741663" cy="420624"/>
+          </a:xfrm>
+          <a:prstGeom prst="roundRect">
+            <a:avLst/>
+          </a:prstGeom>
+          <a:solidFill>
+            <a:srgbClr val="B2EBF2"/>
+          </a:solidFill>
+          <a:ln w="12700">
+            <a:solidFill>
+              <a:srgbClr val="0097A7"/>
+            </a:solidFill>
+          </a:ln>
+          <a:effectLst/>
+        </p:spPr>
+        <p:style>
+          <a:lnRef idx="1">
+            <a:schemeClr val="accent1"/>
+          </a:lnRef>
+          <a:fillRef idx="3">
+            <a:schemeClr val="accent1"/>
+          </a:fillRef>
+          <a:effectRef idx="2">
+            <a:schemeClr val="accent1"/>
+          </a:effectRef>
+          <a:fontRef idx="minor">
+            <a:schemeClr val="lt1"/>
+          </a:fontRef>
+        </p:style>
+        <p:txBody>
+          <a:bodyPr wrap="square" lIns="64008" tIns="18288" rIns="64008" bIns="18288" rtlCol="0" anchor="ctr"/>
+          <a:lstStyle/>
+          <a:p>
+            <a:pPr algn="ctr">
               <a:lnSpc>
-                <a:spcPct val="120000"/>
+                <a:spcPct val="100000"/>
               </a:lnSpc>
-              <a:spcAft>
-                <a:spcPts val="600"/>
-              </a:spcAft>
             </a:pPr>
             <a:r>
-              <a:rPr sz="1250">
+              <a:rPr sz="1000" b="1">
                 <a:solidFill>
                   <a:srgbClr val="212121"/>
+                </a:solidFill>
+                <a:latin typeface="Google Sans Flex SemiBold"/>
+              </a:rPr>
+              <a:t>GEMINI CALL 2 — ORCHESTRATION (real function-calling)</a:t>
+            </a:r>
+          </a:p>
+          <a:p>
+            <a:pPr algn="ctr">
+              <a:lnSpc>
+                <a:spcPct val="100000"/>
+              </a:lnSpc>
+            </a:pPr>
+            <a:r>
+              <a:rPr sz="800" b="0">
+                <a:solidFill>
+                  <a:srgbClr val="595959"/>
                 </a:solidFill>
                 <a:latin typeface="Google Sans Flex"/>
               </a:rPr>
-              <a:t>•  → Gemini multimodal diagnosis call, grounded by RAG retrieval (TF-IDF, hand-rolled in JS) over bilingual English + Kannada disease guides shipped with the site</a:t>
+              <a:t>Decides WHICH tools to invoke from diagnosis + outbreak + near-harvest — not a hardcoded if/else</a:t>
             </a:r>
           </a:p>
-          <a:p>
-            <a:pPr>
+        </p:txBody>
+      </p:sp>
+      <p:sp>
+        <p:nvSpPr>
+          <p:cNvPr id="102" name="TextBox 101"/>
+          <p:cNvSpPr txBox="1"/>
+          <p:nvPr/>
+        </p:nvSpPr>
+        <p:spPr>
+          <a:xfrm>
+            <a:off x="4434840" y="2852928"/>
+            <a:ext cx="274320" cy="146304"/>
+          </a:xfrm>
+          <a:prstGeom prst="rect">
+            <a:avLst/>
+          </a:prstGeom>
+          <a:noFill/>
+        </p:spPr>
+        <p:txBody>
+          <a:bodyPr wrap="none" lIns="0" tIns="0" rIns="0" bIns="0">
+            <a:spAutoFit/>
+          </a:bodyPr>
+          <a:lstStyle/>
+          <a:p>
+            <a:pPr algn="ctr"/>
+            <a:r>
+              <a:rPr sz="1400" b="1">
+                <a:solidFill>
+                  <a:srgbClr val="0097A7"/>
+                </a:solidFill>
+              </a:rPr>
+              <a:t>↓</a:t>
+            </a:r>
+          </a:p>
+        </p:txBody>
+      </p:sp>
+      <p:sp>
+        <p:nvSpPr>
+          <p:cNvPr id="103" name="Rounded Rectangle 102"/>
+          <p:cNvSpPr/>
+          <p:nvPr/>
+        </p:nvSpPr>
+        <p:spPr>
+          <a:xfrm>
+            <a:off x="201168" y="2999232"/>
+            <a:ext cx="2103120" cy="475488"/>
+          </a:xfrm>
+          <a:prstGeom prst="roundRect">
+            <a:avLst/>
+          </a:prstGeom>
+          <a:solidFill>
+            <a:srgbClr val="E8F5E9"/>
+          </a:solidFill>
+          <a:ln w="12700">
+            <a:solidFill>
+              <a:srgbClr val="81C784"/>
+            </a:solidFill>
+          </a:ln>
+          <a:effectLst/>
+        </p:spPr>
+        <p:style>
+          <a:lnRef idx="1">
+            <a:schemeClr val="accent1"/>
+          </a:lnRef>
+          <a:fillRef idx="3">
+            <a:schemeClr val="accent1"/>
+          </a:fillRef>
+          <a:effectRef idx="2">
+            <a:schemeClr val="accent1"/>
+          </a:effectRef>
+          <a:fontRef idx="minor">
+            <a:schemeClr val="lt1"/>
+          </a:fontRef>
+        </p:style>
+        <p:txBody>
+          <a:bodyPr wrap="square" lIns="64008" tIns="18288" rIns="64008" bIns="18288" rtlCol="0" anchor="ctr"/>
+          <a:lstStyle/>
+          <a:p>
+            <a:pPr algn="ctr">
               <a:lnSpc>
-                <a:spcPct val="120000"/>
+                <a:spcPct val="100000"/>
               </a:lnSpc>
-              <a:spcAft>
-                <a:spcPts val="600"/>
-              </a:spcAft>
             </a:pPr>
             <a:r>
-              <a:rPr sz="1250">
+              <a:rPr sz="900" b="1">
                 <a:solidFill>
                   <a:srgbClr val="212121"/>
+                </a:solidFill>
+                <a:latin typeface="Google Sans Flex SemiBold"/>
+              </a:rPr>
+              <a:t>DEALER LOOKUP</a:t>
+            </a:r>
+          </a:p>
+          <a:p>
+            <a:pPr algn="ctr">
+              <a:lnSpc>
+                <a:spcPct val="100000"/>
+              </a:lnSpc>
+            </a:pPr>
+            <a:r>
+              <a:rPr sz="750" b="0">
+                <a:solidFill>
+                  <a:srgbClr val="595959"/>
                 </a:solidFill>
                 <a:latin typeface="Google Sans Flex"/>
               </a:rPr>
-              <a:t>•  → Weather tool call (Open-Meteo) checked before recommending a spray</a:t>
+              <a:t>Nearest in-stock dealer + price</a:t>
             </a:r>
           </a:p>
-          <a:p>
-            <a:pPr>
+        </p:txBody>
+      </p:sp>
+      <p:sp>
+        <p:nvSpPr>
+          <p:cNvPr id="104" name="Rounded Rectangle 103"/>
+          <p:cNvSpPr/>
+          <p:nvPr/>
+        </p:nvSpPr>
+        <p:spPr>
+          <a:xfrm>
+            <a:off x="2414016" y="2999232"/>
+            <a:ext cx="2103120" cy="475488"/>
+          </a:xfrm>
+          <a:prstGeom prst="roundRect">
+            <a:avLst/>
+          </a:prstGeom>
+          <a:solidFill>
+            <a:srgbClr val="E8F5E9"/>
+          </a:solidFill>
+          <a:ln w="12700">
+            <a:solidFill>
+              <a:srgbClr val="81C784"/>
+            </a:solidFill>
+          </a:ln>
+          <a:effectLst/>
+        </p:spPr>
+        <p:style>
+          <a:lnRef idx="1">
+            <a:schemeClr val="accent1"/>
+          </a:lnRef>
+          <a:fillRef idx="3">
+            <a:schemeClr val="accent1"/>
+          </a:fillRef>
+          <a:effectRef idx="2">
+            <a:schemeClr val="accent1"/>
+          </a:effectRef>
+          <a:fontRef idx="minor">
+            <a:schemeClr val="lt1"/>
+          </a:fontRef>
+        </p:style>
+        <p:txBody>
+          <a:bodyPr wrap="square" lIns="64008" tIns="18288" rIns="64008" bIns="18288" rtlCol="0" anchor="ctr"/>
+          <a:lstStyle/>
+          <a:p>
+            <a:pPr algn="ctr">
               <a:lnSpc>
-                <a:spcPct val="120000"/>
+                <a:spcPct val="100000"/>
               </a:lnSpc>
-              <a:spcAft>
-                <a:spcPts val="600"/>
-              </a:spcAft>
             </a:pPr>
             <a:r>
-              <a:rPr sz="1250">
+              <a:rPr sz="900" b="1">
                 <a:solidFill>
                   <a:srgbClr val="212121"/>
+                </a:solidFill>
+                <a:latin typeface="Google Sans Flex SemiBold"/>
+              </a:rPr>
+              <a:t>SELL-PRICE LOOKUP</a:t>
+            </a:r>
+          </a:p>
+          <a:p>
+            <a:pPr algn="ctr">
+              <a:lnSpc>
+                <a:spcPct val="100000"/>
+              </a:lnSpc>
+            </a:pPr>
+            <a:r>
+              <a:rPr sz="750" b="0">
+                <a:solidFill>
+                  <a:srgbClr val="595959"/>
                 </a:solidFill>
                 <a:latin typeface="Google Sans Flex"/>
               </a:rPr>
-              <a:t>•  → A second Gemini call, using real function-calling, decides WHICH of 4 tools to invoke (dealer lookup, sell-price lookup, insurance-claim check, group-buy check) based on the diagnosis, outbreak signal, and near-harvest flag — not a hardcoded if/else</a:t>
+              <a:t>Best nearby mandi price</a:t>
             </a:r>
           </a:p>
-          <a:p>
-            <a:pPr>
+        </p:txBody>
+      </p:sp>
+      <p:sp>
+        <p:nvSpPr>
+          <p:cNvPr id="105" name="Rounded Rectangle 104"/>
+          <p:cNvSpPr/>
+          <p:nvPr/>
+        </p:nvSpPr>
+        <p:spPr>
+          <a:xfrm>
+            <a:off x="4626864" y="2999232"/>
+            <a:ext cx="2103120" cy="475488"/>
+          </a:xfrm>
+          <a:prstGeom prst="roundRect">
+            <a:avLst/>
+          </a:prstGeom>
+          <a:solidFill>
+            <a:srgbClr val="E8F5E9"/>
+          </a:solidFill>
+          <a:ln w="12700">
+            <a:solidFill>
+              <a:srgbClr val="81C784"/>
+            </a:solidFill>
+          </a:ln>
+          <a:effectLst/>
+        </p:spPr>
+        <p:style>
+          <a:lnRef idx="1">
+            <a:schemeClr val="accent1"/>
+          </a:lnRef>
+          <a:fillRef idx="3">
+            <a:schemeClr val="accent1"/>
+          </a:fillRef>
+          <a:effectRef idx="2">
+            <a:schemeClr val="accent1"/>
+          </a:effectRef>
+          <a:fontRef idx="minor">
+            <a:schemeClr val="lt1"/>
+          </a:fontRef>
+        </p:style>
+        <p:txBody>
+          <a:bodyPr wrap="square" lIns="64008" tIns="18288" rIns="64008" bIns="18288" rtlCol="0" anchor="ctr"/>
+          <a:lstStyle/>
+          <a:p>
+            <a:pPr algn="ctr">
               <a:lnSpc>
-                <a:spcPct val="120000"/>
+                <a:spcPct val="100000"/>
               </a:lnSpc>
-              <a:spcAft>
-                <a:spcPts val="600"/>
-              </a:spcAft>
             </a:pPr>
             <a:r>
-              <a:rPr sz="1250">
+              <a:rPr sz="900" b="1">
                 <a:solidFill>
                   <a:srgbClr val="212121"/>
+                </a:solidFill>
+                <a:latin typeface="Google Sans Flex SemiBold"/>
+              </a:rPr>
+              <a:t>INSURANCE CHECK</a:t>
+            </a:r>
+          </a:p>
+          <a:p>
+            <a:pPr algn="ctr">
+              <a:lnSpc>
+                <a:spcPct val="100000"/>
+              </a:lnSpc>
+            </a:pPr>
+            <a:r>
+              <a:rPr sz="750" b="0">
+                <a:solidFill>
+                  <a:srgbClr val="595959"/>
                 </a:solidFill>
                 <a:latin typeface="Google Sans Flex"/>
               </a:rPr>
-              <a:t>•  → Chosen tools run against the known dealer/pricing data; results assembled</a:t>
+              <a:t>Fileable claim packet</a:t>
             </a:r>
           </a:p>
-          <a:p>
-            <a:pPr>
+        </p:txBody>
+      </p:sp>
+      <p:sp>
+        <p:nvSpPr>
+          <p:cNvPr id="106" name="Rounded Rectangle 105"/>
+          <p:cNvSpPr/>
+          <p:nvPr/>
+        </p:nvSpPr>
+        <p:spPr>
+          <a:xfrm>
+            <a:off x="6839712" y="2999232"/>
+            <a:ext cx="2103120" cy="475488"/>
+          </a:xfrm>
+          <a:prstGeom prst="roundRect">
+            <a:avLst/>
+          </a:prstGeom>
+          <a:solidFill>
+            <a:srgbClr val="E8F5E9"/>
+          </a:solidFill>
+          <a:ln w="12700">
+            <a:solidFill>
+              <a:srgbClr val="81C784"/>
+            </a:solidFill>
+          </a:ln>
+          <a:effectLst/>
+        </p:spPr>
+        <p:style>
+          <a:lnRef idx="1">
+            <a:schemeClr val="accent1"/>
+          </a:lnRef>
+          <a:fillRef idx="3">
+            <a:schemeClr val="accent1"/>
+          </a:fillRef>
+          <a:effectRef idx="2">
+            <a:schemeClr val="accent1"/>
+          </a:effectRef>
+          <a:fontRef idx="minor">
+            <a:schemeClr val="lt1"/>
+          </a:fontRef>
+        </p:style>
+        <p:txBody>
+          <a:bodyPr wrap="square" lIns="64008" tIns="18288" rIns="64008" bIns="18288" rtlCol="0" anchor="ctr"/>
+          <a:lstStyle/>
+          <a:p>
+            <a:pPr algn="ctr">
               <a:lnSpc>
-                <a:spcPct val="120000"/>
+                <a:spcPct val="100000"/>
               </a:lnSpc>
-              <a:spcAft>
-                <a:spcPts val="600"/>
-              </a:spcAft>
             </a:pPr>
             <a:r>
-              <a:rPr sz="1250">
+              <a:rPr sz="900" b="1">
                 <a:solidFill>
                   <a:srgbClr val="212121"/>
+                </a:solidFill>
+                <a:latin typeface="Google Sans Flex SemiBold"/>
+              </a:rPr>
+              <a:t>GROUP-BUY CHECK</a:t>
+            </a:r>
+          </a:p>
+          <a:p>
+            <a:pPr algn="ctr">
+              <a:lnSpc>
+                <a:spcPct val="100000"/>
+              </a:lnSpc>
+            </a:pPr>
+            <a:r>
+              <a:rPr sz="750" b="0">
+                <a:solidFill>
+                  <a:srgbClr val="595959"/>
                 </a:solidFill>
                 <a:latin typeface="Google Sans Flex"/>
               </a:rPr>
-              <a:t>•  → Advisory translated to Kannada, spoken via the browser's own Web Speech API if a kn-IN voice is available</a:t>
+              <a:t>Bulk-discount alert</a:t>
             </a:r>
           </a:p>
-          <a:p>
-            <a:pPr>
+        </p:txBody>
+      </p:sp>
+      <p:sp>
+        <p:nvSpPr>
+          <p:cNvPr id="107" name="TextBox 106"/>
+          <p:cNvSpPr txBox="1"/>
+          <p:nvPr/>
+        </p:nvSpPr>
+        <p:spPr>
+          <a:xfrm>
+            <a:off x="4434840" y="3474720"/>
+            <a:ext cx="274320" cy="146304"/>
+          </a:xfrm>
+          <a:prstGeom prst="rect">
+            <a:avLst/>
+          </a:prstGeom>
+          <a:noFill/>
+        </p:spPr>
+        <p:txBody>
+          <a:bodyPr wrap="none" lIns="0" tIns="0" rIns="0" bIns="0">
+            <a:spAutoFit/>
+          </a:bodyPr>
+          <a:lstStyle/>
+          <a:p>
+            <a:pPr algn="ctr"/>
+            <a:r>
+              <a:rPr sz="1400" b="1">
+                <a:solidFill>
+                  <a:srgbClr val="B0B0B0"/>
+                </a:solidFill>
+              </a:rPr>
+              <a:t>↓</a:t>
+            </a:r>
+          </a:p>
+        </p:txBody>
+      </p:sp>
+      <p:sp>
+        <p:nvSpPr>
+          <p:cNvPr id="108" name="Rounded Rectangle 107"/>
+          <p:cNvSpPr/>
+          <p:nvPr/>
+        </p:nvSpPr>
+        <p:spPr>
+          <a:xfrm>
+            <a:off x="201168" y="3621024"/>
+            <a:ext cx="8741663" cy="420624"/>
+          </a:xfrm>
+          <a:prstGeom prst="roundRect">
+            <a:avLst/>
+          </a:prstGeom>
+          <a:solidFill>
+            <a:srgbClr val="F1F1F1"/>
+          </a:solidFill>
+          <a:ln w="12700">
+            <a:solidFill>
+              <a:srgbClr val="B0B0B0"/>
+            </a:solidFill>
+          </a:ln>
+          <a:effectLst/>
+        </p:spPr>
+        <p:style>
+          <a:lnRef idx="1">
+            <a:schemeClr val="accent1"/>
+          </a:lnRef>
+          <a:fillRef idx="3">
+            <a:schemeClr val="accent1"/>
+          </a:fillRef>
+          <a:effectRef idx="2">
+            <a:schemeClr val="accent1"/>
+          </a:effectRef>
+          <a:fontRef idx="minor">
+            <a:schemeClr val="lt1"/>
+          </a:fontRef>
+        </p:style>
+        <p:txBody>
+          <a:bodyPr wrap="square" lIns="64008" tIns="18288" rIns="64008" bIns="18288" rtlCol="0" anchor="ctr"/>
+          <a:lstStyle/>
+          <a:p>
+            <a:pPr algn="ctr">
               <a:lnSpc>
-                <a:spcPct val="120000"/>
+                <a:spcPct val="100000"/>
               </a:lnSpc>
-              <a:spcAft>
-                <a:spcPts val="600"/>
-              </a:spcAft>
             </a:pPr>
             <a:r>
-              <a:rPr sz="1250">
+              <a:rPr sz="1000" b="1">
                 <a:solidFill>
                   <a:srgbClr val="212121"/>
+                </a:solidFill>
+                <a:latin typeface="Google Sans Flex SemiBold"/>
+              </a:rPr>
+              <a:t>RESPONSE ASSEMBLY</a:t>
+            </a:r>
+          </a:p>
+          <a:p>
+            <a:pPr algn="ctr">
+              <a:lnSpc>
+                <a:spcPct val="100000"/>
+              </a:lnSpc>
+            </a:pPr>
+            <a:r>
+              <a:rPr sz="800" b="0">
+                <a:solidFill>
+                  <a:srgbClr val="595959"/>
                 </a:solidFill>
                 <a:latin typeface="Google Sans Flex"/>
               </a:rPr>
-              <a:t>•  → Response rendered: diagnosis, dealer card, outbreak banner, insurance packet, group-buy card</a:t>
+              <a:t>Kannada advisory spoken via Web Speech API; diagnosis, dealer, outbreak, insurance, group-buy cards rendered</a:t>
             </a:r>
           </a:p>
-          <a:p>
-            <a:pPr>
+        </p:txBody>
+      </p:sp>
+      <p:sp>
+        <p:nvSpPr>
+          <p:cNvPr id="109" name="Rounded Rectangle 108"/>
+          <p:cNvSpPr/>
+          <p:nvPr/>
+        </p:nvSpPr>
+        <p:spPr>
+          <a:xfrm>
+            <a:off x="201168" y="4169664"/>
+            <a:ext cx="8741663" cy="420624"/>
+          </a:xfrm>
+          <a:prstGeom prst="roundRect">
+            <a:avLst/>
+          </a:prstGeom>
+          <a:solidFill>
+            <a:srgbClr val="E3F2FD"/>
+          </a:solidFill>
+          <a:ln w="12700">
+            <a:solidFill>
+              <a:srgbClr val="0097A7"/>
+            </a:solidFill>
+          </a:ln>
+          <a:effectLst/>
+        </p:spPr>
+        <p:style>
+          <a:lnRef idx="1">
+            <a:schemeClr val="accent1"/>
+          </a:lnRef>
+          <a:fillRef idx="3">
+            <a:schemeClr val="accent1"/>
+          </a:fillRef>
+          <a:effectRef idx="2">
+            <a:schemeClr val="accent1"/>
+          </a:effectRef>
+          <a:fontRef idx="minor">
+            <a:schemeClr val="lt1"/>
+          </a:fontRef>
+        </p:style>
+        <p:txBody>
+          <a:bodyPr wrap="square" lIns="64008" tIns="18288" rIns="64008" bIns="18288" rtlCol="0" anchor="ctr"/>
+          <a:lstStyle/>
+          <a:p>
+            <a:pPr algn="ctr">
               <a:lnSpc>
-                <a:spcPct val="120000"/>
+                <a:spcPct val="100000"/>
               </a:lnSpc>
-              <a:spcAft>
-                <a:spcPts val="600"/>
-              </a:spcAft>
             </a:pPr>
             <a:r>
-              <a:rPr sz="1250">
-                <a:solidFill>
-                  <a:srgbClr val="212121"/>
+              <a:rPr sz="850" b="0">
+                <a:solidFill>
+                  <a:srgbClr val="595959"/>
                 </a:solidFill>
                 <a:latin typeface="Google Sans Flex"/>
               </a:rPr>
-              <a:t>•  → Separately: district dashboard loads a pre-aggregated, anonymized village-level snapshot built at deploy time, never raw farmer data</a:t>
+              <a:t>Separately — district dashboard: a pre-aggregated, anonymized village-level snapshot loads independently, built at deploy time. Raw farmer data never reaches the browser.</a:t>
             </a:r>
           </a:p>
         </p:txBody>
@@ -10383,7 +10815,7 @@
 </p:sld>
 </file>
 
-<file path=ppt/slides/slide7.xml><?xml version="1.0" encoding="utf-8"?>
+<file path=ppt/slides/slide6.xml><?xml version="1.0" encoding="utf-8"?>
 <p:sld xmlns:a="http://schemas.openxmlformats.org/drawingml/2006/main" xmlns:r="http://schemas.openxmlformats.org/officeDocument/2006/relationships" xmlns:p="http://schemas.openxmlformats.org/presentationml/2006/main">
   <p:cSld>
     <p:spTree>
@@ -10606,7 +11038,7 @@
 </p:sld>
 </file>
 
-<file path=ppt/slides/slide8.xml><?xml version="1.0" encoding="utf-8"?>
+<file path=ppt/slides/slide7.xml><?xml version="1.0" encoding="utf-8"?>
 <p:sld xmlns:a="http://schemas.openxmlformats.org/drawingml/2006/main" xmlns:r="http://schemas.openxmlformats.org/officeDocument/2006/relationships" xmlns:p="http://schemas.openxmlformats.org/presentationml/2006/main">
   <p:cSld>
     <p:spTree>
@@ -10781,8 +11213,8 @@
         </p:nvSpPr>
         <p:spPr>
           <a:xfrm>
-            <a:off x="265176" y="1280160"/>
-            <a:ext cx="8595360" cy="3566160"/>
+            <a:off x="201168" y="1364462"/>
+            <a:ext cx="640080" cy="215444"/>
           </a:xfrm>
           <a:prstGeom prst="rect">
             <a:avLst/>
@@ -10790,122 +11222,1036 @@
           <a:noFill/>
         </p:spPr>
         <p:txBody>
-          <a:bodyPr wrap="square">
+          <a:bodyPr wrap="square" lIns="0" rIns="0" anchor="ctr">
             <a:spAutoFit/>
           </a:bodyPr>
           <a:lstStyle/>
           <a:p>
-            <a:pPr>
+            <a:pPr algn="l"/>
+            <a:r>
+              <a:rPr lang="en-IN" sz="800" b="1">
+                <a:solidFill>
+                  <a:srgbClr val="595959"/>
+                </a:solidFill>
+                <a:latin typeface="Google Sans Flex SemiBold"/>
+              </a:rPr>
+              <a:t>HOSTING</a:t>
+            </a:r>
+          </a:p>
+        </p:txBody>
+      </p:sp>
+      <p:sp>
+        <p:nvSpPr>
+          <p:cNvPr id="113" name="Rounded Rectangle 112"/>
+          <p:cNvSpPr/>
+          <p:nvPr/>
+        </p:nvSpPr>
+        <p:spPr>
+          <a:xfrm>
+            <a:off x="914400" y="1280160"/>
+            <a:ext cx="8028431" cy="384048"/>
+          </a:xfrm>
+          <a:prstGeom prst="roundRect">
+            <a:avLst/>
+          </a:prstGeom>
+          <a:solidFill>
+            <a:srgbClr val="FFF3E0"/>
+          </a:solidFill>
+          <a:ln w="12700">
+            <a:solidFill>
+              <a:srgbClr val="FFB74D"/>
+            </a:solidFill>
+          </a:ln>
+          <a:effectLst/>
+        </p:spPr>
+        <p:style>
+          <a:lnRef idx="1">
+            <a:schemeClr val="accent1"/>
+          </a:lnRef>
+          <a:fillRef idx="3">
+            <a:schemeClr val="accent1"/>
+          </a:fillRef>
+          <a:effectRef idx="2">
+            <a:schemeClr val="accent1"/>
+          </a:effectRef>
+          <a:fontRef idx="minor">
+            <a:schemeClr val="lt1"/>
+          </a:fontRef>
+        </p:style>
+        <p:txBody>
+          <a:bodyPr wrap="square" lIns="64008" tIns="18288" rIns="64008" bIns="18288" rtlCol="0" anchor="ctr"/>
+          <a:lstStyle/>
+          <a:p>
+            <a:pPr algn="ctr">
               <a:lnSpc>
-                <a:spcPct val="120000"/>
+                <a:spcPct val="100000"/>
               </a:lnSpc>
-              <a:spcAft>
-                <a:spcPts val="600"/>
-              </a:spcAft>
             </a:pPr>
             <a:r>
-              <a:rPr sz="1300">
+              <a:rPr sz="950" b="1">
                 <a:solidFill>
                   <a:srgbClr val="212121"/>
+                </a:solidFill>
+                <a:latin typeface="Google Sans Flex SemiBold"/>
+              </a:rPr>
+              <a:t>FIREBASE HOSTING — FREE SPARK PLAN</a:t>
+            </a:r>
+          </a:p>
+          <a:p>
+            <a:pPr algn="ctr">
+              <a:lnSpc>
+                <a:spcPct val="100000"/>
+              </a:lnSpc>
+            </a:pPr>
+            <a:r>
+              <a:rPr sz="800" b="0">
+                <a:solidFill>
+                  <a:srgbClr val="595959"/>
                 </a:solidFill>
                 <a:latin typeface="Google Sans Flex"/>
               </a:rPr>
-              <a:t>•  100% client-side static site — no backend server, no billing account, no credit card anywhere in the deployed stack — Firebase Hosting (free Spark plan) serves the app</a:t>
+              <a:t>Static site only. $0 billing, no credit card anywhere in the stack.</a:t>
             </a:r>
           </a:p>
-          <a:p>
-            <a:pPr>
+        </p:txBody>
+      </p:sp>
+      <p:sp>
+        <p:nvSpPr>
+          <p:cNvPr id="114" name="TextBox 113"/>
+          <p:cNvSpPr txBox="1"/>
+          <p:nvPr/>
+        </p:nvSpPr>
+        <p:spPr>
+          <a:xfrm>
+            <a:off x="4791455" y="1773936"/>
+            <a:ext cx="274320" cy="128016"/>
+          </a:xfrm>
+          <a:prstGeom prst="rect">
+            <a:avLst/>
+          </a:prstGeom>
+          <a:noFill/>
+        </p:spPr>
+        <p:txBody>
+          <a:bodyPr wrap="none" lIns="0" tIns="0" rIns="0" bIns="0">
+            <a:spAutoFit/>
+          </a:bodyPr>
+          <a:lstStyle/>
+          <a:p>
+            <a:pPr algn="ctr"/>
+            <a:r>
+              <a:rPr sz="1400" b="1">
+                <a:solidFill>
+                  <a:srgbClr val="B0B0B0"/>
+                </a:solidFill>
+              </a:rPr>
+              <a:t>↓</a:t>
+            </a:r>
+          </a:p>
+        </p:txBody>
+      </p:sp>
+      <p:sp>
+        <p:nvSpPr>
+          <p:cNvPr id="115" name="TextBox 114"/>
+          <p:cNvSpPr txBox="1"/>
+          <p:nvPr/>
+        </p:nvSpPr>
+        <p:spPr>
+          <a:xfrm>
+            <a:off x="201168" y="1901952"/>
+            <a:ext cx="640080" cy="457200"/>
+          </a:xfrm>
+          <a:prstGeom prst="rect">
+            <a:avLst/>
+          </a:prstGeom>
+          <a:noFill/>
+        </p:spPr>
+        <p:txBody>
+          <a:bodyPr wrap="square" lIns="0" rIns="0" anchor="ctr">
+            <a:spAutoFit/>
+          </a:bodyPr>
+          <a:lstStyle/>
+          <a:p>
+            <a:pPr algn="l"/>
+            <a:r>
+              <a:rPr sz="800" b="1">
+                <a:solidFill>
+                  <a:srgbClr val="595959"/>
+                </a:solidFill>
+                <a:latin typeface="Google Sans Flex SemiBold"/>
+              </a:rPr>
+              <a:t>BROWSER</a:t>
+            </a:r>
+          </a:p>
+        </p:txBody>
+      </p:sp>
+      <p:sp>
+        <p:nvSpPr>
+          <p:cNvPr id="116" name="Rounded Rectangle 115"/>
+          <p:cNvSpPr/>
+          <p:nvPr/>
+        </p:nvSpPr>
+        <p:spPr>
+          <a:xfrm>
+            <a:off x="914400" y="1901952"/>
+            <a:ext cx="2602991" cy="457200"/>
+          </a:xfrm>
+          <a:prstGeom prst="roundRect">
+            <a:avLst/>
+          </a:prstGeom>
+          <a:solidFill>
+            <a:srgbClr val="F1F1F1"/>
+          </a:solidFill>
+          <a:ln w="12700">
+            <a:solidFill>
+              <a:srgbClr val="B0B0B0"/>
+            </a:solidFill>
+          </a:ln>
+          <a:effectLst/>
+        </p:spPr>
+        <p:style>
+          <a:lnRef idx="1">
+            <a:schemeClr val="accent1"/>
+          </a:lnRef>
+          <a:fillRef idx="3">
+            <a:schemeClr val="accent1"/>
+          </a:fillRef>
+          <a:effectRef idx="2">
+            <a:schemeClr val="accent1"/>
+          </a:effectRef>
+          <a:fontRef idx="minor">
+            <a:schemeClr val="lt1"/>
+          </a:fontRef>
+        </p:style>
+        <p:txBody>
+          <a:bodyPr wrap="square" lIns="64008" tIns="18288" rIns="64008" bIns="18288" rtlCol="0" anchor="ctr"/>
+          <a:lstStyle/>
+          <a:p>
+            <a:pPr algn="ctr">
               <a:lnSpc>
-                <a:spcPct val="120000"/>
+                <a:spcPct val="100000"/>
               </a:lnSpc>
-              <a:spcAft>
-                <a:spcPts val="600"/>
-              </a:spcAft>
             </a:pPr>
             <a:r>
-              <a:rPr sz="1300">
+              <a:rPr sz="900" b="1">
                 <a:solidFill>
                   <a:srgbClr val="212121"/>
+                </a:solidFill>
+                <a:latin typeface="Google Sans Flex SemiBold"/>
+              </a:rPr>
+              <a:t>CAMERA / MIC INPUT</a:t>
+            </a:r>
+          </a:p>
+          <a:p>
+            <a:pPr algn="ctr">
+              <a:lnSpc>
+                <a:spcPct val="100000"/>
+              </a:lnSpc>
+            </a:pPr>
+            <a:r>
+              <a:rPr sz="750" b="0">
+                <a:solidFill>
+                  <a:srgbClr val="595959"/>
                 </a:solidFill>
                 <a:latin typeface="Google Sans Flex"/>
               </a:rPr>
-              <a:t>•  Diagnosis: a real Gemini multimodal API call direct from the browser, grounded by a hand-rolled TF-IDF + cosine-similarity RAG index over 18 disease documents (9 English + 9 Kannada), so a Kannada symptom description retrieves relevant passages natively</a:t>
+              <a:t>Photo + Kannada speech, Web Speech API</a:t>
             </a:r>
           </a:p>
-          <a:p>
-            <a:pPr>
+        </p:txBody>
+      </p:sp>
+      <p:sp>
+        <p:nvSpPr>
+          <p:cNvPr id="117" name="Rounded Rectangle 116"/>
+          <p:cNvSpPr/>
+          <p:nvPr/>
+        </p:nvSpPr>
+        <p:spPr>
+          <a:xfrm>
+            <a:off x="3627119" y="1901952"/>
+            <a:ext cx="2602991" cy="457200"/>
+          </a:xfrm>
+          <a:prstGeom prst="roundRect">
+            <a:avLst/>
+          </a:prstGeom>
+          <a:solidFill>
+            <a:srgbClr val="F1F1F1"/>
+          </a:solidFill>
+          <a:ln w="12700">
+            <a:solidFill>
+              <a:srgbClr val="B0B0B0"/>
+            </a:solidFill>
+          </a:ln>
+          <a:effectLst/>
+        </p:spPr>
+        <p:style>
+          <a:lnRef idx="1">
+            <a:schemeClr val="accent1"/>
+          </a:lnRef>
+          <a:fillRef idx="3">
+            <a:schemeClr val="accent1"/>
+          </a:fillRef>
+          <a:effectRef idx="2">
+            <a:schemeClr val="accent1"/>
+          </a:effectRef>
+          <a:fontRef idx="minor">
+            <a:schemeClr val="lt1"/>
+          </a:fontRef>
+        </p:style>
+        <p:txBody>
+          <a:bodyPr wrap="square" lIns="64008" tIns="18288" rIns="64008" bIns="18288" rtlCol="0" anchor="ctr"/>
+          <a:lstStyle/>
+          <a:p>
+            <a:pPr algn="ctr">
               <a:lnSpc>
-                <a:spcPct val="120000"/>
+                <a:spcPct val="100000"/>
               </a:lnSpc>
-              <a:spcAft>
-                <a:spcPts val="600"/>
-              </a:spcAft>
             </a:pPr>
             <a:r>
-              <a:rPr sz="1300">
+              <a:rPr sz="900" b="1">
                 <a:solidFill>
                   <a:srgbClr val="212121"/>
+                </a:solidFill>
+                <a:latin typeface="Google Sans Flex SemiBold"/>
+              </a:rPr>
+              <a:t>UI RENDER</a:t>
+            </a:r>
+          </a:p>
+          <a:p>
+            <a:pPr algn="ctr">
+              <a:lnSpc>
+                <a:spcPct val="100000"/>
+              </a:lnSpc>
+            </a:pPr>
+            <a:r>
+              <a:rPr sz="750" b="0">
+                <a:solidFill>
+                  <a:srgbClr val="595959"/>
                 </a:solidFill>
                 <a:latin typeface="Google Sans Flex"/>
               </a:rPr>
-              <a:t>•  Orchestration: a second Gemini call uses real function-calling (tools/functionDeclarations) to decide which of 4 downstream tools to invoke — the model drives the decision, not a hardcoded branch — falling back to equivalent deterministic rules only if the live call fails after retries</a:t>
+              <a:t>Diagnosis, dealer, outbreak, insurance, group-buy cards</a:t>
             </a:r>
           </a:p>
-          <a:p>
-            <a:pPr>
+        </p:txBody>
+      </p:sp>
+      <p:sp>
+        <p:nvSpPr>
+          <p:cNvPr id="118" name="Rounded Rectangle 117"/>
+          <p:cNvSpPr/>
+          <p:nvPr/>
+        </p:nvSpPr>
+        <p:spPr>
+          <a:xfrm>
+            <a:off x="6339839" y="1901952"/>
+            <a:ext cx="2602991" cy="457200"/>
+          </a:xfrm>
+          <a:prstGeom prst="roundRect">
+            <a:avLst/>
+          </a:prstGeom>
+          <a:solidFill>
+            <a:srgbClr val="F1F1F1"/>
+          </a:solidFill>
+          <a:ln w="12700">
+            <a:solidFill>
+              <a:srgbClr val="B0B0B0"/>
+            </a:solidFill>
+          </a:ln>
+          <a:effectLst/>
+        </p:spPr>
+        <p:style>
+          <a:lnRef idx="1">
+            <a:schemeClr val="accent1"/>
+          </a:lnRef>
+          <a:fillRef idx="3">
+            <a:schemeClr val="accent1"/>
+          </a:fillRef>
+          <a:effectRef idx="2">
+            <a:schemeClr val="accent1"/>
+          </a:effectRef>
+          <a:fontRef idx="minor">
+            <a:schemeClr val="lt1"/>
+          </a:fontRef>
+        </p:style>
+        <p:txBody>
+          <a:bodyPr wrap="square" lIns="64008" tIns="18288" rIns="64008" bIns="18288" rtlCol="0" anchor="ctr"/>
+          <a:lstStyle/>
+          <a:p>
+            <a:pPr algn="ctr">
               <a:lnSpc>
-                <a:spcPct val="120000"/>
+                <a:spcPct val="100000"/>
               </a:lnSpc>
-              <a:spcAft>
-                <a:spcPts val="600"/>
-              </a:spcAft>
             </a:pPr>
             <a:r>
-              <a:rPr sz="1300">
+              <a:rPr sz="900" b="1">
                 <a:solidFill>
                   <a:srgbClr val="212121"/>
+                </a:solidFill>
+                <a:latin typeface="Google Sans Flex SemiBold"/>
+              </a:rPr>
+              <a:t>VOICE OUTPUT</a:t>
+            </a:r>
+          </a:p>
+          <a:p>
+            <a:pPr algn="ctr">
+              <a:lnSpc>
+                <a:spcPct val="100000"/>
+              </a:lnSpc>
+            </a:pPr>
+            <a:r>
+              <a:rPr sz="750" b="0">
+                <a:solidFill>
+                  <a:srgbClr val="595959"/>
                 </a:solidFill>
                 <a:latin typeface="Google Sans Flex"/>
               </a:rPr>
-              <a:t>•  Weather: a direct, keyless call to the free Open-Meteo API (confirmed CORS-enabled)</a:t>
+              <a:t>SpeechSynthesis, kn-IN voice feature-detect</a:t>
             </a:r>
           </a:p>
-          <a:p>
-            <a:pPr>
+        </p:txBody>
+      </p:sp>
+      <p:sp>
+        <p:nvSpPr>
+          <p:cNvPr id="119" name="TextBox 118"/>
+          <p:cNvSpPr txBox="1"/>
+          <p:nvPr/>
+        </p:nvSpPr>
+        <p:spPr>
+          <a:xfrm>
+            <a:off x="4791455" y="2450592"/>
+            <a:ext cx="274320" cy="128016"/>
+          </a:xfrm>
+          <a:prstGeom prst="rect">
+            <a:avLst/>
+          </a:prstGeom>
+          <a:noFill/>
+        </p:spPr>
+        <p:txBody>
+          <a:bodyPr wrap="none" lIns="0" tIns="0" rIns="0" bIns="0">
+            <a:spAutoFit/>
+          </a:bodyPr>
+          <a:lstStyle/>
+          <a:p>
+            <a:pPr algn="ctr"/>
+            <a:r>
+              <a:rPr sz="1400" b="1">
+                <a:solidFill>
+                  <a:srgbClr val="B0B0B0"/>
+                </a:solidFill>
+              </a:rPr>
+              <a:t>↓</a:t>
+            </a:r>
+          </a:p>
+        </p:txBody>
+      </p:sp>
+      <p:sp>
+        <p:nvSpPr>
+          <p:cNvPr id="120" name="TextBox 119"/>
+          <p:cNvSpPr txBox="1"/>
+          <p:nvPr/>
+        </p:nvSpPr>
+        <p:spPr>
+          <a:xfrm>
+            <a:off x="201168" y="2578608"/>
+            <a:ext cx="640080" cy="512064"/>
+          </a:xfrm>
+          <a:prstGeom prst="rect">
+            <a:avLst/>
+          </a:prstGeom>
+          <a:noFill/>
+        </p:spPr>
+        <p:txBody>
+          <a:bodyPr wrap="square" lIns="0" rIns="0" anchor="ctr">
+            <a:spAutoFit/>
+          </a:bodyPr>
+          <a:lstStyle/>
+          <a:p>
+            <a:pPr algn="l"/>
+            <a:r>
+              <a:rPr sz="800" b="1">
+                <a:solidFill>
+                  <a:srgbClr val="595959"/>
+                </a:solidFill>
+                <a:latin typeface="Google Sans Flex SemiBold"/>
+              </a:rPr>
+              <a:t>GEMINI API</a:t>
+            </a:r>
+          </a:p>
+        </p:txBody>
+      </p:sp>
+      <p:sp>
+        <p:nvSpPr>
+          <p:cNvPr id="121" name="Rounded Rectangle 120"/>
+          <p:cNvSpPr/>
+          <p:nvPr/>
+        </p:nvSpPr>
+        <p:spPr>
+          <a:xfrm>
+            <a:off x="914400" y="2578608"/>
+            <a:ext cx="3959352" cy="512064"/>
+          </a:xfrm>
+          <a:prstGeom prst="roundRect">
+            <a:avLst/>
+          </a:prstGeom>
+          <a:solidFill>
+            <a:srgbClr val="B2EBF2"/>
+          </a:solidFill>
+          <a:ln w="12700">
+            <a:solidFill>
+              <a:srgbClr val="0097A7"/>
+            </a:solidFill>
+          </a:ln>
+          <a:effectLst/>
+        </p:spPr>
+        <p:style>
+          <a:lnRef idx="1">
+            <a:schemeClr val="accent1"/>
+          </a:lnRef>
+          <a:fillRef idx="3">
+            <a:schemeClr val="accent1"/>
+          </a:fillRef>
+          <a:effectRef idx="2">
+            <a:schemeClr val="accent1"/>
+          </a:effectRef>
+          <a:fontRef idx="minor">
+            <a:schemeClr val="lt1"/>
+          </a:fontRef>
+        </p:style>
+        <p:txBody>
+          <a:bodyPr wrap="square" lIns="64008" tIns="18288" rIns="64008" bIns="18288" rtlCol="0" anchor="ctr"/>
+          <a:lstStyle/>
+          <a:p>
+            <a:pPr algn="ctr">
               <a:lnSpc>
-                <a:spcPct val="120000"/>
+                <a:spcPct val="100000"/>
               </a:lnSpc>
-              <a:spcAft>
-                <a:spcPts val="600"/>
-              </a:spcAft>
             </a:pPr>
             <a:r>
-              <a:rPr sz="1300">
+              <a:rPr sz="950" b="1">
                 <a:solidFill>
                   <a:srgbClr val="212121"/>
+                </a:solidFill>
+                <a:latin typeface="Google Sans Flex SemiBold"/>
+              </a:rPr>
+              <a:t>CALL 1 — DIAGNOSIS</a:t>
+            </a:r>
+          </a:p>
+          <a:p>
+            <a:pPr algn="ctr">
+              <a:lnSpc>
+                <a:spcPct val="100000"/>
+              </a:lnSpc>
+            </a:pPr>
+            <a:r>
+              <a:rPr sz="800" b="0">
+                <a:solidFill>
+                  <a:srgbClr val="595959"/>
                 </a:solidFill>
                 <a:latin typeface="Google Sans Flex"/>
               </a:rPr>
-              <a:t>•  Dealer directory, mandi prices, and diagnosis history ship as static JSON/CSV with the site; the district dashboard loads a pre-aggregated snapshot built at deploy time from the private farmer dataset, so raw farmer/plot linkage never ships publicly</a:t>
+              <a:t>Multimodal + RAG-grounded structured JSON output</a:t>
             </a:r>
           </a:p>
-          <a:p>
-            <a:pPr>
+        </p:txBody>
+      </p:sp>
+      <p:sp>
+        <p:nvSpPr>
+          <p:cNvPr id="122" name="Rounded Rectangle 121"/>
+          <p:cNvSpPr/>
+          <p:nvPr/>
+        </p:nvSpPr>
+        <p:spPr>
+          <a:xfrm>
+            <a:off x="4983480" y="2578608"/>
+            <a:ext cx="3959352" cy="512064"/>
+          </a:xfrm>
+          <a:prstGeom prst="roundRect">
+            <a:avLst/>
+          </a:prstGeom>
+          <a:solidFill>
+            <a:srgbClr val="B2EBF2"/>
+          </a:solidFill>
+          <a:ln w="12700">
+            <a:solidFill>
+              <a:srgbClr val="0097A7"/>
+            </a:solidFill>
+          </a:ln>
+          <a:effectLst/>
+        </p:spPr>
+        <p:style>
+          <a:lnRef idx="1">
+            <a:schemeClr val="accent1"/>
+          </a:lnRef>
+          <a:fillRef idx="3">
+            <a:schemeClr val="accent1"/>
+          </a:fillRef>
+          <a:effectRef idx="2">
+            <a:schemeClr val="accent1"/>
+          </a:effectRef>
+          <a:fontRef idx="minor">
+            <a:schemeClr val="lt1"/>
+          </a:fontRef>
+        </p:style>
+        <p:txBody>
+          <a:bodyPr wrap="square" lIns="64008" tIns="18288" rIns="64008" bIns="18288" rtlCol="0" anchor="ctr"/>
+          <a:lstStyle/>
+          <a:p>
+            <a:pPr algn="ctr">
               <a:lnSpc>
-                <a:spcPct val="120000"/>
+                <a:spcPct val="100000"/>
               </a:lnSpc>
-              <a:spcAft>
-                <a:spcPts val="600"/>
-              </a:spcAft>
             </a:pPr>
             <a:r>
-              <a:rPr sz="1300">
+              <a:rPr sz="950" b="1">
                 <a:solidFill>
                   <a:srgbClr val="212121"/>
+                </a:solidFill>
+                <a:latin typeface="Google Sans Flex SemiBold"/>
+              </a:rPr>
+              <a:t>CALL 2 — ORCHESTRATION</a:t>
+            </a:r>
+          </a:p>
+          <a:p>
+            <a:pPr algn="ctr">
+              <a:lnSpc>
+                <a:spcPct val="100000"/>
+              </a:lnSpc>
+            </a:pPr>
+            <a:r>
+              <a:rPr sz="800" b="0">
+                <a:solidFill>
+                  <a:srgbClr val="595959"/>
                 </a:solidFill>
                 <a:latin typeface="Google Sans Flex"/>
               </a:rPr>
-              <a:t>•  Voice advisory: the browser's own Web Speech API (SpeechSynthesis), feature-detecting a kn-IN voice at runtime</a:t>
+              <a:t>Real function-calling picks which tools fire; retries, then deterministic fallback</a:t>
+            </a:r>
+          </a:p>
+        </p:txBody>
+      </p:sp>
+      <p:sp>
+        <p:nvSpPr>
+          <p:cNvPr id="123" name="TextBox 122"/>
+          <p:cNvSpPr txBox="1"/>
+          <p:nvPr/>
+        </p:nvSpPr>
+        <p:spPr>
+          <a:xfrm>
+            <a:off x="4791455" y="3182112"/>
+            <a:ext cx="274320" cy="128016"/>
+          </a:xfrm>
+          <a:prstGeom prst="rect">
+            <a:avLst/>
+          </a:prstGeom>
+          <a:noFill/>
+        </p:spPr>
+        <p:txBody>
+          <a:bodyPr wrap="none" lIns="0" tIns="0" rIns="0" bIns="0">
+            <a:spAutoFit/>
+          </a:bodyPr>
+          <a:lstStyle/>
+          <a:p>
+            <a:pPr algn="ctr"/>
+            <a:r>
+              <a:rPr sz="1400" b="1">
+                <a:solidFill>
+                  <a:srgbClr val="0097A7"/>
+                </a:solidFill>
+              </a:rPr>
+              <a:t>↓</a:t>
+            </a:r>
+          </a:p>
+        </p:txBody>
+      </p:sp>
+      <p:sp>
+        <p:nvSpPr>
+          <p:cNvPr id="124" name="TextBox 123"/>
+          <p:cNvSpPr txBox="1"/>
+          <p:nvPr/>
+        </p:nvSpPr>
+        <p:spPr>
+          <a:xfrm>
+            <a:off x="201168" y="3310128"/>
+            <a:ext cx="640080" cy="530352"/>
+          </a:xfrm>
+          <a:prstGeom prst="rect">
+            <a:avLst/>
+          </a:prstGeom>
+          <a:noFill/>
+        </p:spPr>
+        <p:txBody>
+          <a:bodyPr wrap="square" lIns="0" rIns="0" anchor="ctr">
+            <a:spAutoFit/>
+          </a:bodyPr>
+          <a:lstStyle/>
+          <a:p>
+            <a:pPr algn="l"/>
+            <a:r>
+              <a:rPr sz="800" b="1">
+                <a:solidFill>
+                  <a:srgbClr val="595959"/>
+                </a:solidFill>
+                <a:latin typeface="Google Sans Flex SemiBold"/>
+              </a:rPr>
+              <a:t>DATA &amp; APIs</a:t>
+            </a:r>
+          </a:p>
+        </p:txBody>
+      </p:sp>
+      <p:sp>
+        <p:nvSpPr>
+          <p:cNvPr id="125" name="Rounded Rectangle 124"/>
+          <p:cNvSpPr/>
+          <p:nvPr/>
+        </p:nvSpPr>
+        <p:spPr>
+          <a:xfrm>
+            <a:off x="914400" y="3310128"/>
+            <a:ext cx="1924812" cy="530352"/>
+          </a:xfrm>
+          <a:prstGeom prst="roundRect">
+            <a:avLst/>
+          </a:prstGeom>
+          <a:solidFill>
+            <a:srgbClr val="E8F5E9"/>
+          </a:solidFill>
+          <a:ln w="12700">
+            <a:solidFill>
+              <a:srgbClr val="81C784"/>
+            </a:solidFill>
+          </a:ln>
+          <a:effectLst/>
+        </p:spPr>
+        <p:style>
+          <a:lnRef idx="1">
+            <a:schemeClr val="accent1"/>
+          </a:lnRef>
+          <a:fillRef idx="3">
+            <a:schemeClr val="accent1"/>
+          </a:fillRef>
+          <a:effectRef idx="2">
+            <a:schemeClr val="accent1"/>
+          </a:effectRef>
+          <a:fontRef idx="minor">
+            <a:schemeClr val="lt1"/>
+          </a:fontRef>
+        </p:style>
+        <p:txBody>
+          <a:bodyPr wrap="square" lIns="64008" tIns="18288" rIns="64008" bIns="18288" rtlCol="0" anchor="ctr"/>
+          <a:lstStyle/>
+          <a:p>
+            <a:pPr algn="ctr">
+              <a:lnSpc>
+                <a:spcPct val="100000"/>
+              </a:lnSpc>
+            </a:pPr>
+            <a:r>
+              <a:rPr sz="900" b="1">
+                <a:solidFill>
+                  <a:srgbClr val="212121"/>
+                </a:solidFill>
+                <a:latin typeface="Google Sans Flex SemiBold"/>
+              </a:rPr>
+              <a:t>RAG INDEX (JS)</a:t>
+            </a:r>
+          </a:p>
+          <a:p>
+            <a:pPr algn="ctr">
+              <a:lnSpc>
+                <a:spcPct val="100000"/>
+              </a:lnSpc>
+            </a:pPr>
+            <a:r>
+              <a:rPr sz="750" b="0">
+                <a:solidFill>
+                  <a:srgbClr val="595959"/>
+                </a:solidFill>
+                <a:latin typeface="Google Sans Flex"/>
+              </a:rPr>
+              <a:t>TF-IDF + cosine, 18 bilingual disease docs</a:t>
+            </a:r>
+          </a:p>
+        </p:txBody>
+      </p:sp>
+      <p:sp>
+        <p:nvSpPr>
+          <p:cNvPr id="126" name="Rounded Rectangle 125"/>
+          <p:cNvSpPr/>
+          <p:nvPr/>
+        </p:nvSpPr>
+        <p:spPr>
+          <a:xfrm>
+            <a:off x="2948940" y="3310128"/>
+            <a:ext cx="1924812" cy="530352"/>
+          </a:xfrm>
+          <a:prstGeom prst="roundRect">
+            <a:avLst/>
+          </a:prstGeom>
+          <a:solidFill>
+            <a:srgbClr val="E8F5E9"/>
+          </a:solidFill>
+          <a:ln w="12700">
+            <a:solidFill>
+              <a:srgbClr val="81C784"/>
+            </a:solidFill>
+          </a:ln>
+          <a:effectLst/>
+        </p:spPr>
+        <p:style>
+          <a:lnRef idx="1">
+            <a:schemeClr val="accent1"/>
+          </a:lnRef>
+          <a:fillRef idx="3">
+            <a:schemeClr val="accent1"/>
+          </a:fillRef>
+          <a:effectRef idx="2">
+            <a:schemeClr val="accent1"/>
+          </a:effectRef>
+          <a:fontRef idx="minor">
+            <a:schemeClr val="lt1"/>
+          </a:fontRef>
+        </p:style>
+        <p:txBody>
+          <a:bodyPr wrap="square" lIns="64008" tIns="18288" rIns="64008" bIns="18288" rtlCol="0" anchor="ctr"/>
+          <a:lstStyle/>
+          <a:p>
+            <a:pPr algn="ctr">
+              <a:lnSpc>
+                <a:spcPct val="100000"/>
+              </a:lnSpc>
+            </a:pPr>
+            <a:r>
+              <a:rPr sz="900" b="1">
+                <a:solidFill>
+                  <a:srgbClr val="212121"/>
+                </a:solidFill>
+                <a:latin typeface="Google Sans Flex SemiBold"/>
+              </a:rPr>
+              <a:t>STATIC JSON/CSV</a:t>
+            </a:r>
+          </a:p>
+          <a:p>
+            <a:pPr algn="ctr">
+              <a:lnSpc>
+                <a:spcPct val="100000"/>
+              </a:lnSpc>
+            </a:pPr>
+            <a:r>
+              <a:rPr sz="750" b="0">
+                <a:solidFill>
+                  <a:srgbClr val="595959"/>
+                </a:solidFill>
+                <a:latin typeface="Google Sans Flex"/>
+              </a:rPr>
+              <a:t>Dealers, mandi prices, diagnosis history</a:t>
+            </a:r>
+          </a:p>
+        </p:txBody>
+      </p:sp>
+      <p:sp>
+        <p:nvSpPr>
+          <p:cNvPr id="127" name="Rounded Rectangle 126"/>
+          <p:cNvSpPr/>
+          <p:nvPr/>
+        </p:nvSpPr>
+        <p:spPr>
+          <a:xfrm>
+            <a:off x="4983480" y="3310128"/>
+            <a:ext cx="1924812" cy="530352"/>
+          </a:xfrm>
+          <a:prstGeom prst="roundRect">
+            <a:avLst/>
+          </a:prstGeom>
+          <a:solidFill>
+            <a:srgbClr val="E8F5E9"/>
+          </a:solidFill>
+          <a:ln w="12700">
+            <a:solidFill>
+              <a:srgbClr val="81C784"/>
+            </a:solidFill>
+          </a:ln>
+          <a:effectLst/>
+        </p:spPr>
+        <p:style>
+          <a:lnRef idx="1">
+            <a:schemeClr val="accent1"/>
+          </a:lnRef>
+          <a:fillRef idx="3">
+            <a:schemeClr val="accent1"/>
+          </a:fillRef>
+          <a:effectRef idx="2">
+            <a:schemeClr val="accent1"/>
+          </a:effectRef>
+          <a:fontRef idx="minor">
+            <a:schemeClr val="lt1"/>
+          </a:fontRef>
+        </p:style>
+        <p:txBody>
+          <a:bodyPr wrap="square" lIns="64008" tIns="18288" rIns="64008" bIns="18288" rtlCol="0" anchor="ctr"/>
+          <a:lstStyle/>
+          <a:p>
+            <a:pPr algn="ctr">
+              <a:lnSpc>
+                <a:spcPct val="100000"/>
+              </a:lnSpc>
+            </a:pPr>
+            <a:r>
+              <a:rPr sz="900" b="1">
+                <a:solidFill>
+                  <a:srgbClr val="212121"/>
+                </a:solidFill>
+                <a:latin typeface="Google Sans Flex SemiBold"/>
+              </a:rPr>
+              <a:t>DASHBOARD SNAPSHOT</a:t>
+            </a:r>
+          </a:p>
+          <a:p>
+            <a:pPr algn="ctr">
+              <a:lnSpc>
+                <a:spcPct val="100000"/>
+              </a:lnSpc>
+            </a:pPr>
+            <a:r>
+              <a:rPr sz="750" b="0">
+                <a:solidFill>
+                  <a:srgbClr val="595959"/>
+                </a:solidFill>
+                <a:latin typeface="Google Sans Flex"/>
+              </a:rPr>
+              <a:t>Pre-aggregated at deploy time — raw farmer data never ships</a:t>
+            </a:r>
+          </a:p>
+        </p:txBody>
+      </p:sp>
+      <p:sp>
+        <p:nvSpPr>
+          <p:cNvPr id="128" name="Rounded Rectangle 127"/>
+          <p:cNvSpPr/>
+          <p:nvPr/>
+        </p:nvSpPr>
+        <p:spPr>
+          <a:xfrm>
+            <a:off x="7018020" y="3310128"/>
+            <a:ext cx="1924812" cy="530352"/>
+          </a:xfrm>
+          <a:prstGeom prst="roundRect">
+            <a:avLst/>
+          </a:prstGeom>
+          <a:solidFill>
+            <a:srgbClr val="E8F5E9"/>
+          </a:solidFill>
+          <a:ln w="12700">
+            <a:solidFill>
+              <a:srgbClr val="81C784"/>
+            </a:solidFill>
+          </a:ln>
+          <a:effectLst/>
+        </p:spPr>
+        <p:style>
+          <a:lnRef idx="1">
+            <a:schemeClr val="accent1"/>
+          </a:lnRef>
+          <a:fillRef idx="3">
+            <a:schemeClr val="accent1"/>
+          </a:fillRef>
+          <a:effectRef idx="2">
+            <a:schemeClr val="accent1"/>
+          </a:effectRef>
+          <a:fontRef idx="minor">
+            <a:schemeClr val="lt1"/>
+          </a:fontRef>
+        </p:style>
+        <p:txBody>
+          <a:bodyPr wrap="square" lIns="64008" tIns="18288" rIns="64008" bIns="18288" rtlCol="0" anchor="ctr"/>
+          <a:lstStyle/>
+          <a:p>
+            <a:pPr algn="ctr">
+              <a:lnSpc>
+                <a:spcPct val="100000"/>
+              </a:lnSpc>
+            </a:pPr>
+            <a:r>
+              <a:rPr sz="900" b="1">
+                <a:solidFill>
+                  <a:srgbClr val="212121"/>
+                </a:solidFill>
+                <a:latin typeface="Google Sans Flex SemiBold"/>
+              </a:rPr>
+              <a:t>OPEN-METEO</a:t>
+            </a:r>
+          </a:p>
+          <a:p>
+            <a:pPr algn="ctr">
+              <a:lnSpc>
+                <a:spcPct val="100000"/>
+              </a:lnSpc>
+            </a:pPr>
+            <a:r>
+              <a:rPr sz="750" b="0">
+                <a:solidFill>
+                  <a:srgbClr val="595959"/>
+                </a:solidFill>
+                <a:latin typeface="Google Sans Flex"/>
+              </a:rPr>
+              <a:t>Keyless, CORS-enabled weather API</a:t>
+            </a:r>
+          </a:p>
+        </p:txBody>
+      </p:sp>
+      <p:sp>
+        <p:nvSpPr>
+          <p:cNvPr id="129" name="Rounded Rectangle 128"/>
+          <p:cNvSpPr/>
+          <p:nvPr/>
+        </p:nvSpPr>
+        <p:spPr>
+          <a:xfrm>
+            <a:off x="201168" y="3986784"/>
+            <a:ext cx="8741664" cy="384048"/>
+          </a:xfrm>
+          <a:prstGeom prst="roundRect">
+            <a:avLst/>
+          </a:prstGeom>
+          <a:solidFill>
+            <a:srgbClr val="E3F2FD"/>
+          </a:solidFill>
+          <a:ln w="12700">
+            <a:solidFill>
+              <a:srgbClr val="0097A7"/>
+            </a:solidFill>
+          </a:ln>
+          <a:effectLst/>
+        </p:spPr>
+        <p:style>
+          <a:lnRef idx="1">
+            <a:schemeClr val="accent1"/>
+          </a:lnRef>
+          <a:fillRef idx="3">
+            <a:schemeClr val="accent1"/>
+          </a:fillRef>
+          <a:effectRef idx="2">
+            <a:schemeClr val="accent1"/>
+          </a:effectRef>
+          <a:fontRef idx="minor">
+            <a:schemeClr val="lt1"/>
+          </a:fontRef>
+        </p:style>
+        <p:txBody>
+          <a:bodyPr wrap="square" lIns="64008" tIns="18288" rIns="64008" bIns="18288" rtlCol="0" anchor="ctr"/>
+          <a:lstStyle/>
+          <a:p>
+            <a:pPr algn="ctr">
+              <a:lnSpc>
+                <a:spcPct val="100000"/>
+              </a:lnSpc>
+            </a:pPr>
+            <a:r>
+              <a:rPr sz="850" b="0">
+                <a:solidFill>
+                  <a:srgbClr val="595959"/>
+                </a:solidFill>
+                <a:latin typeface="Google Sans Flex"/>
+              </a:rPr>
+              <a:t>No backend server anywhere in this stack — every call above runs directly from the farmer's browser to a public API or a static file.</a:t>
             </a:r>
           </a:p>
         </p:txBody>
@@ -10918,7 +12264,7 @@
 </p:sld>
 </file>
 
-<file path=ppt/slides/slide9.xml><?xml version="1.0" encoding="utf-8"?>
+<file path=ppt/slides/slide8.xml><?xml version="1.0" encoding="utf-8"?>
 <p:sld xmlns:a="http://schemas.openxmlformats.org/drawingml/2006/main" xmlns:r="http://schemas.openxmlformats.org/officeDocument/2006/relationships" xmlns:p="http://schemas.openxmlformats.org/presentationml/2006/main">
   <p:cSld>
     <p:spTree>
@@ -11256,6 +12602,299 @@
                 <a:latin typeface="Google Sans Flex"/>
               </a:rPr>
               <a:t>•  Python (data generation, build-time dashboard aggregation), Playwright (verification)</a:t>
+            </a:r>
+          </a:p>
+        </p:txBody>
+      </p:sp>
+    </p:spTree>
+  </p:cSld>
+  <p:clrMapOvr>
+    <a:masterClrMapping/>
+  </p:clrMapOvr>
+</p:sld>
+</file>
+
+<file path=ppt/slides/slide9.xml><?xml version="1.0" encoding="utf-8"?>
+<p:sld xmlns:a="http://schemas.openxmlformats.org/drawingml/2006/main" xmlns:r="http://schemas.openxmlformats.org/officeDocument/2006/relationships" xmlns:p="http://schemas.openxmlformats.org/presentationml/2006/main">
+  <p:cSld>
+    <p:spTree>
+      <p:nvGrpSpPr>
+        <p:cNvPr id="1" name="Shape 123"/>
+        <p:cNvGrpSpPr/>
+        <p:nvPr/>
+      </p:nvGrpSpPr>
+      <p:grpSpPr>
+        <a:xfrm>
+          <a:off x="0" y="0"/>
+          <a:ext cx="0" cy="0"/>
+          <a:chOff x="0" y="0"/>
+          <a:chExt cx="0" cy="0"/>
+        </a:xfrm>
+      </p:grpSpPr>
+      <p:pic>
+        <p:nvPicPr>
+          <p:cNvPr id="124" name="Google Shape;124;p22" title="Frame 144.png"/>
+          <p:cNvPicPr preferRelativeResize="0"/>
+          <p:nvPr/>
+        </p:nvPicPr>
+        <p:blipFill rotWithShape="1">
+          <a:blip r:embed="rId3">
+            <a:alphaModFix/>
+          </a:blip>
+          <a:srcRect b="98001"/>
+          <a:stretch/>
+        </p:blipFill>
+        <p:spPr>
+          <a:xfrm>
+            <a:off x="0" y="5093562"/>
+            <a:ext cx="9144000" cy="54275"/>
+          </a:xfrm>
+          <a:prstGeom prst="rect">
+            <a:avLst/>
+          </a:prstGeom>
+          <a:noFill/>
+          <a:ln>
+            <a:noFill/>
+          </a:ln>
+        </p:spPr>
+      </p:pic>
+      <p:pic>
+        <p:nvPicPr>
+          <p:cNvPr id="125" name="Google Shape;125;p22" title="Group 427319979.png"/>
+          <p:cNvPicPr preferRelativeResize="0"/>
+          <p:nvPr/>
+        </p:nvPicPr>
+        <p:blipFill>
+          <a:blip r:embed="rId4">
+            <a:alphaModFix/>
+          </a:blip>
+          <a:stretch>
+            <a:fillRect/>
+          </a:stretch>
+        </p:blipFill>
+        <p:spPr>
+          <a:xfrm>
+            <a:off x="0" y="1"/>
+            <a:ext cx="9144000" cy="507359"/>
+          </a:xfrm>
+          <a:prstGeom prst="rect">
+            <a:avLst/>
+          </a:prstGeom>
+          <a:noFill/>
+          <a:ln>
+            <a:noFill/>
+          </a:ln>
+        </p:spPr>
+      </p:pic>
+      <p:sp>
+        <p:nvSpPr>
+          <p:cNvPr id="126" name="Google Shape;126;p22"/>
+          <p:cNvSpPr/>
+          <p:nvPr/>
+        </p:nvSpPr>
+        <p:spPr>
+          <a:xfrm>
+            <a:off x="-29250" y="5071875"/>
+            <a:ext cx="9173400" cy="97800"/>
+          </a:xfrm>
+          <a:prstGeom prst="rect">
+            <a:avLst/>
+          </a:prstGeom>
+          <a:solidFill>
+            <a:schemeClr val="dk1"/>
+          </a:solidFill>
+          <a:ln>
+            <a:noFill/>
+          </a:ln>
+        </p:spPr>
+        <p:txBody>
+          <a:bodyPr spcFirstLastPara="1" wrap="square" lIns="91425" tIns="91425" rIns="91425" bIns="91425" anchor="ctr" anchorCtr="0">
+            <a:noAutofit/>
+          </a:bodyPr>
+          <a:lstStyle/>
+          <a:p>
+            <a:pPr marL="0" lvl="0" indent="0" algn="ctr" rtl="0">
+              <a:spcBef>
+                <a:spcPts val="0"/>
+              </a:spcBef>
+              <a:spcAft>
+                <a:spcPts val="0"/>
+              </a:spcAft>
+              <a:buNone/>
+            </a:pPr>
+            <a:endParaRPr/>
+          </a:p>
+        </p:txBody>
+      </p:sp>
+      <p:sp>
+        <p:nvSpPr>
+          <p:cNvPr id="127" name="Google Shape;127;p22"/>
+          <p:cNvSpPr txBox="1"/>
+          <p:nvPr/>
+        </p:nvSpPr>
+        <p:spPr>
+          <a:xfrm>
+            <a:off x="265350" y="663825"/>
+            <a:ext cx="8943000" cy="561900"/>
+          </a:xfrm>
+          <a:prstGeom prst="rect">
+            <a:avLst/>
+          </a:prstGeom>
+          <a:noFill/>
+          <a:ln>
+            <a:noFill/>
+          </a:ln>
+        </p:spPr>
+        <p:txBody>
+          <a:bodyPr spcFirstLastPara="1" wrap="square" lIns="91425" tIns="91425" rIns="91425" bIns="91425" anchor="t" anchorCtr="0">
+            <a:noAutofit/>
+          </a:bodyPr>
+          <a:lstStyle/>
+          <a:p>
+            <a:pPr marL="0" lvl="0" indent="0" algn="l" rtl="0">
+              <a:lnSpc>
+                <a:spcPct val="115000"/>
+              </a:lnSpc>
+              <a:spcBef>
+                <a:spcPts val="0"/>
+              </a:spcBef>
+              <a:spcAft>
+                <a:spcPts val="0"/>
+              </a:spcAft>
+              <a:buNone/>
+            </a:pPr>
+            <a:r>
+              <a:rPr sz="1600">
+                <a:solidFill>
+                  <a:srgbClr val="212121"/>
+                </a:solidFill>
+                <a:latin typeface="Google Sans Flex Medium"/>
+              </a:rPr>
+              <a:t>Estimated implementation cost</a:t>
+            </a:r>
+            <a:endParaRPr sz="1600">
+              <a:latin typeface="Google Sans Flex Medium"/>
+              <a:ea typeface="Google Sans Flex Medium"/>
+              <a:cs typeface="Google Sans Flex Medium"/>
+              <a:sym typeface="Google Sans Flex Medium"/>
+            </a:endParaRPr>
+          </a:p>
+        </p:txBody>
+      </p:sp>
+      <p:sp>
+        <p:nvSpPr>
+          <p:cNvPr id="128" name="TextBox 127"/>
+          <p:cNvSpPr txBox="1"/>
+          <p:nvPr/>
+        </p:nvSpPr>
+        <p:spPr>
+          <a:xfrm>
+            <a:off x="265176" y="1280160"/>
+            <a:ext cx="8595360" cy="3566160"/>
+          </a:xfrm>
+          <a:prstGeom prst="rect">
+            <a:avLst/>
+          </a:prstGeom>
+          <a:noFill/>
+        </p:spPr>
+        <p:txBody>
+          <a:bodyPr wrap="square">
+            <a:spAutoFit/>
+          </a:bodyPr>
+          <a:lstStyle/>
+          <a:p>
+            <a:pPr>
+              <a:lnSpc>
+                <a:spcPct val="120000"/>
+              </a:lnSpc>
+              <a:spcAft>
+                <a:spcPts val="600"/>
+              </a:spcAft>
+            </a:pPr>
+            <a:r>
+              <a:rPr sz="1400">
+                <a:solidFill>
+                  <a:srgbClr val="212121"/>
+                </a:solidFill>
+                <a:latin typeface="Google Sans Flex"/>
+              </a:rPr>
+              <a:t>•  Current deployed cost: $0 — no billing account, no credit card, anywhere in the stack</a:t>
+            </a:r>
+          </a:p>
+          <a:p>
+            <a:pPr>
+              <a:lnSpc>
+                <a:spcPct val="120000"/>
+              </a:lnSpc>
+              <a:spcAft>
+                <a:spcPts val="600"/>
+              </a:spcAft>
+            </a:pPr>
+            <a:r>
+              <a:rPr sz="1400">
+                <a:solidFill>
+                  <a:srgbClr val="212121"/>
+                </a:solidFill>
+                <a:latin typeface="Google Sans Flex"/>
+              </a:rPr>
+              <a:t>•  Firebase Hosting: free Spark plan, no usage cap reached at this scale</a:t>
+            </a:r>
+          </a:p>
+          <a:p>
+            <a:pPr>
+              <a:lnSpc>
+                <a:spcPct val="120000"/>
+              </a:lnSpc>
+              <a:spcAft>
+                <a:spcPts val="600"/>
+              </a:spcAft>
+            </a:pPr>
+            <a:r>
+              <a:rPr sz="1400">
+                <a:solidFill>
+                  <a:srgbClr val="212121"/>
+                </a:solidFill>
+                <a:latin typeface="Google Sans Flex"/>
+              </a:rPr>
+              <a:t>•  Gemini API: free tier via Google AI Studio — 20 requests/day per project for gemini-3.8-flash; each diagnosis now uses 2 calls (diagnosis + orchestration), so roughly 10 full diagnoses/day before the app gracefully falls back to deterministic logic for the rest of the day</a:t>
+            </a:r>
+          </a:p>
+          <a:p>
+            <a:pPr>
+              <a:lnSpc>
+                <a:spcPct val="120000"/>
+              </a:lnSpc>
+              <a:spcAft>
+                <a:spcPts val="600"/>
+              </a:spcAft>
+            </a:pPr>
+            <a:r>
+              <a:rPr sz="1400">
+                <a:solidFill>
+                  <a:srgbClr val="212121"/>
+                </a:solidFill>
+                <a:latin typeface="Google Sans Flex"/>
+              </a:rPr>
+              <a:t>•  Open-Meteo, Web Speech API: free, no quota observed in testing</a:t>
+            </a:r>
+          </a:p>
+          <a:p>
+            <a:pPr>
+              <a:lnSpc>
+                <a:spcPct val="120000"/>
+              </a:lnSpc>
+              <a:spcAft>
+                <a:spcPts val="600"/>
+              </a:spcAft>
+            </a:pPr>
+            <a:r>
+              <a:rPr sz="1400">
+                <a:solidFill>
+                  <a:srgbClr val="212121"/>
+                </a:solidFill>
+                <a:latin typeface="Google Sans Flex"/>
+              </a:rPr>
+              <a:t>•  Scaling beyond the free tier: upgrading to a paid Gemini tier is the only cost that would be needed to raise the daily diagnosis cap — no other paid service is required even at higher usage, since there is no backend, database, or search service to scale</a:t>
             </a:r>
           </a:p>
         </p:txBody>

</xml_diff>

<commit_message>
Add the demo video link to the submission deck's Links slide
Links to the GitHub raw file (github.com/.../raw/main/docs/video/
Kisan_Mitra_Demo.mp4) rather than a GitHub blob-view URL -- GitHub's
web UI refuses to preview video files past a small size threshold
("we can't show files that are this big right now"), but the raw link
still serves the exact same, verified-uncorrupted file directly.
Reduced the links textbox's body size slightly (14pt -> 13pt) so the
longer URL wraps cleanly without overflowing the slide.

Co-Authored-By: Claude Sonnet 5 <noreply@anthropic.com>
</commit_message>
<xml_diff>
--- a/docs/Kisan_Mitra_Submission.pptx
+++ b/docs/Kisan_Mitra_Submission.pptx
@@ -8377,7 +8377,7 @@
               </a:lnSpc>
             </a:pPr>
             <a:r>
-              <a:rPr sz="1400">
+              <a:rPr sz="1300">
                 <a:solidFill>
                   <a:srgbClr val="212121"/>
                 </a:solidFill>
@@ -8393,13 +8393,13 @@
               </a:lnSpc>
             </a:pPr>
             <a:r>
-              <a:rPr sz="1400">
+              <a:rPr sz="1300">
                 <a:solidFill>
                   <a:srgbClr val="212121"/>
                 </a:solidFill>
                 <a:latin typeface="Google Sans Flex"/>
               </a:rPr>
-              <a:t>Demo Video Link (3 Minutes): [add link before submission]</a:t>
+              <a:t>Demo Video Link (3 Minutes): https://github.com/Kavitacs08/kisan-mitra/raw/main/docs/video/Kisan_Mitra_Demo.mp4</a:t>
             </a:r>
           </a:p>
           <a:p>
@@ -8409,7 +8409,7 @@
               </a:lnSpc>
             </a:pPr>
             <a:r>
-              <a:rPr sz="1400">
+              <a:rPr sz="1300">
                 <a:solidFill>
                   <a:srgbClr val="212121"/>
                 </a:solidFill>

</xml_diff>